<commit_message>
Use verified production receipt in Demo Day deck
</commit_message>
<xml_diff>
--- a/casezero/submission/02-deck/Axiom-Demo-Day-Deck.pptx
+++ b/casezero/submission/02-deck/Axiom-Demo-Day-Deck.pptx
@@ -2,26 +2,26 @@
 <file path=ppt/presentation.xml><?xml version="1.0" encoding="utf-8"?>
 <p:presentation xmlns:p="http://schemas.openxmlformats.org/presentationml/2006/main">
   <p:sldMasterIdLst>
-    <p:sldMasterId xmlns:r="http://schemas.openxmlformats.org/officeDocument/2006/relationships" id="2147483648" r:id="R27c0724ff833481d"/>
+    <p:sldMasterId xmlns:r="http://schemas.openxmlformats.org/officeDocument/2006/relationships" id="2147483648" r:id="Ra8f68d3763c44d43"/>
   </p:sldMasterIdLst>
   <p:notesMasterIdLst>
-    <p:notesMasterId xmlns:r="http://schemas.openxmlformats.org/officeDocument/2006/relationships" r:id="R38b80c1218024382"/>
+    <p:notesMasterId xmlns:r="http://schemas.openxmlformats.org/officeDocument/2006/relationships" r:id="R39c3d50feddb4aa6"/>
   </p:notesMasterIdLst>
   <p:sldIdLst>
-    <p:sldId xmlns:r="http://schemas.openxmlformats.org/officeDocument/2006/relationships" id="256" r:id="Ref846723b2eb4352"/>
-    <p:sldId xmlns:r="http://schemas.openxmlformats.org/officeDocument/2006/relationships" id="257" r:id="R5986fd15b6414ff0"/>
-    <p:sldId xmlns:r="http://schemas.openxmlformats.org/officeDocument/2006/relationships" id="258" r:id="R8241f62854ff4e37"/>
-    <p:sldId xmlns:r="http://schemas.openxmlformats.org/officeDocument/2006/relationships" id="259" r:id="R88979e8f60f24d4d"/>
-    <p:sldId xmlns:r="http://schemas.openxmlformats.org/officeDocument/2006/relationships" id="260" r:id="R268d9c2cba4c448c"/>
-    <p:sldId xmlns:r="http://schemas.openxmlformats.org/officeDocument/2006/relationships" id="261" r:id="R99b18fb3c1f94c68"/>
-    <p:sldId xmlns:r="http://schemas.openxmlformats.org/officeDocument/2006/relationships" id="262" r:id="Rdd7897e2a1d44290"/>
-    <p:sldId xmlns:r="http://schemas.openxmlformats.org/officeDocument/2006/relationships" id="263" r:id="Rcf661fa9c5bc4187"/>
-    <p:sldId xmlns:r="http://schemas.openxmlformats.org/officeDocument/2006/relationships" id="264" r:id="R9c331b7ee29a4a6b"/>
-    <p:sldId xmlns:r="http://schemas.openxmlformats.org/officeDocument/2006/relationships" id="265" r:id="R132934ff75ba43b4"/>
-    <p:sldId xmlns:r="http://schemas.openxmlformats.org/officeDocument/2006/relationships" id="266" r:id="Ra88f929693374889"/>
-    <p:sldId xmlns:r="http://schemas.openxmlformats.org/officeDocument/2006/relationships" id="267" r:id="Re7baf2c11ce64663"/>
-    <p:sldId xmlns:r="http://schemas.openxmlformats.org/officeDocument/2006/relationships" id="268" r:id="R9e9211ce62574cbc"/>
-    <p:sldId xmlns:r="http://schemas.openxmlformats.org/officeDocument/2006/relationships" id="269" r:id="Rd65dea187aff47a7"/>
+    <p:sldId xmlns:r="http://schemas.openxmlformats.org/officeDocument/2006/relationships" id="256" r:id="Rfd78bd5c4e43467f"/>
+    <p:sldId xmlns:r="http://schemas.openxmlformats.org/officeDocument/2006/relationships" id="257" r:id="Re8b8278afafb49cc"/>
+    <p:sldId xmlns:r="http://schemas.openxmlformats.org/officeDocument/2006/relationships" id="258" r:id="R9e202d65b6214f21"/>
+    <p:sldId xmlns:r="http://schemas.openxmlformats.org/officeDocument/2006/relationships" id="259" r:id="R4866a1fe39da44b9"/>
+    <p:sldId xmlns:r="http://schemas.openxmlformats.org/officeDocument/2006/relationships" id="260" r:id="R0572c7dade684539"/>
+    <p:sldId xmlns:r="http://schemas.openxmlformats.org/officeDocument/2006/relationships" id="261" r:id="Rac4998f91ab2475a"/>
+    <p:sldId xmlns:r="http://schemas.openxmlformats.org/officeDocument/2006/relationships" id="262" r:id="Rbf447578475741a9"/>
+    <p:sldId xmlns:r="http://schemas.openxmlformats.org/officeDocument/2006/relationships" id="263" r:id="Rda96c14b00e544a9"/>
+    <p:sldId xmlns:r="http://schemas.openxmlformats.org/officeDocument/2006/relationships" id="264" r:id="R214f567f49c34c87"/>
+    <p:sldId xmlns:r="http://schemas.openxmlformats.org/officeDocument/2006/relationships" id="265" r:id="Rdfe891eb673e4f6f"/>
+    <p:sldId xmlns:r="http://schemas.openxmlformats.org/officeDocument/2006/relationships" id="266" r:id="Ra542d4e6bd044047"/>
+    <p:sldId xmlns:r="http://schemas.openxmlformats.org/officeDocument/2006/relationships" id="267" r:id="R86e9a98de109468a"/>
+    <p:sldId xmlns:r="http://schemas.openxmlformats.org/officeDocument/2006/relationships" id="268" r:id="R4dbde6b6048a4c5b"/>
+    <p:sldId xmlns:r="http://schemas.openxmlformats.org/officeDocument/2006/relationships" id="269" r:id="Rcae2d44c375a492a"/>
   </p:sldIdLst>
   <p:sldSz cx="12192000" cy="6858000"/>
   <p:notesSz cx="6858000" cy="9144000"/>
@@ -1913,7 +1913,7 @@
   </p:cSld>
   <p:clrMap bg1="lt1" tx1="dk1" bg2="lt2" tx2="dk2" accent1="accent1" accent2="accent2" accent3="accent3" accent4="accent4" accent5="accent5" accent6="accent6" hlink="hlink" folHlink="folHlink"/>
   <p:sldLayoutIdLst>
-    <p:sldLayoutId xmlns:r="http://schemas.openxmlformats.org/officeDocument/2006/relationships" id="2147483649" r:id="Rede5e01270504528"/>
+    <p:sldLayoutId xmlns:r="http://schemas.openxmlformats.org/officeDocument/2006/relationships" id="2147483649" r:id="R1afcca7419d64e28"/>
   </p:sldLayoutIdLst>
   <p:txStyles>
     <p:titleStyle>
@@ -2464,7 +2464,7 @@
           <p:cNvPr id="12" name="">
             <a:extLst xmlns:a="http://schemas.openxmlformats.org/drawingml/2006/main">
               <a:ext uri="{FF2B5EF4-FFF2-40B4-BE49-F238E27FC236}">
-                <a16:creationId xmlns:a16="http://schemas.microsoft.com/office/drawing/2014/main" id="{41078576-4DDD-48F0-B2A5-7EC73D68A163}"/>
+                <a16:creationId xmlns:a16="http://schemas.microsoft.com/office/drawing/2014/main" id="{B6CDAA56-0AB9-4EB2-B5A0-BAFCB1AEDA9C}"/>
               </a:ext>
             </a:extLst>
           </p:cNvPr>
@@ -2514,7 +2514,7 @@
           <p:cNvPr id="2" name="">
             <a:extLst xmlns:a="http://schemas.openxmlformats.org/drawingml/2006/main">
               <a:ext uri="{FF2B5EF4-FFF2-40B4-BE49-F238E27FC236}">
-                <a16:creationId xmlns:a16="http://schemas.microsoft.com/office/drawing/2014/main" id="{6323878E-D248-4AD3-A7F7-98E28ED30CAF}"/>
+                <a16:creationId xmlns:a16="http://schemas.microsoft.com/office/drawing/2014/main" id="{3EC7A55F-7F4D-4C32-B045-12F08792E887}"/>
               </a:ext>
             </a:extLst>
           </p:cNvPr>
@@ -2564,7 +2564,7 @@
           <p:cNvPr id="3" name="">
             <a:extLst xmlns:a="http://schemas.openxmlformats.org/drawingml/2006/main">
               <a:ext uri="{FF2B5EF4-FFF2-40B4-BE49-F238E27FC236}">
-                <a16:creationId xmlns:a16="http://schemas.microsoft.com/office/drawing/2014/main" id="{31AA714C-B2C6-4201-8D08-FBFA4748CB09}"/>
+                <a16:creationId xmlns:a16="http://schemas.microsoft.com/office/drawing/2014/main" id="{F1C05B18-032F-4C02-B8CD-C091A15AC8D7}"/>
               </a:ext>
             </a:extLst>
           </p:cNvPr>
@@ -2614,7 +2614,7 @@
           <p:cNvPr id="4" name="">
             <a:extLst xmlns:a="http://schemas.openxmlformats.org/drawingml/2006/main">
               <a:ext uri="{FF2B5EF4-FFF2-40B4-BE49-F238E27FC236}">
-                <a16:creationId xmlns:a16="http://schemas.microsoft.com/office/drawing/2014/main" id="{6DA123AE-A311-4462-ABFC-6E917890A799}"/>
+                <a16:creationId xmlns:a16="http://schemas.microsoft.com/office/drawing/2014/main" id="{6D307526-723A-4B56-93EE-2BC4E7C20D65}"/>
               </a:ext>
             </a:extLst>
           </p:cNvPr>
@@ -2649,7 +2649,7 @@
           <p:cNvPr id="5" name="">
             <a:extLst xmlns:a="http://schemas.openxmlformats.org/drawingml/2006/main">
               <a:ext uri="{FF2B5EF4-FFF2-40B4-BE49-F238E27FC236}">
-                <a16:creationId xmlns:a16="http://schemas.microsoft.com/office/drawing/2014/main" id="{8946901F-573E-4FEA-8504-FD5D8B7E07BF}"/>
+                <a16:creationId xmlns:a16="http://schemas.microsoft.com/office/drawing/2014/main" id="{2DB2296E-E605-4778-8DCE-E87A8C4D75A9}"/>
               </a:ext>
             </a:extLst>
           </p:cNvPr>
@@ -2699,7 +2699,7 @@
           <p:cNvPr id="6" name="">
             <a:extLst xmlns:a="http://schemas.openxmlformats.org/drawingml/2006/main">
               <a:ext uri="{FF2B5EF4-FFF2-40B4-BE49-F238E27FC236}">
-                <a16:creationId xmlns:a16="http://schemas.microsoft.com/office/drawing/2014/main" id="{A0C0987F-B78C-41DC-A483-4C5422A1FBE2}"/>
+                <a16:creationId xmlns:a16="http://schemas.microsoft.com/office/drawing/2014/main" id="{AA7FDB38-F47E-46FE-AF59-A4FA25345A2E}"/>
               </a:ext>
             </a:extLst>
           </p:cNvPr>
@@ -2766,7 +2766,7 @@
           <p:cNvPr id="7" name="">
             <a:extLst xmlns:a="http://schemas.openxmlformats.org/drawingml/2006/main">
               <a:ext uri="{FF2B5EF4-FFF2-40B4-BE49-F238E27FC236}">
-                <a16:creationId xmlns:a16="http://schemas.microsoft.com/office/drawing/2014/main" id="{6264D771-E5FC-4189-9125-99E75A333077}"/>
+                <a16:creationId xmlns:a16="http://schemas.microsoft.com/office/drawing/2014/main" id="{126ADB41-39EE-4137-8642-7079173E72E2}"/>
               </a:ext>
             </a:extLst>
           </p:cNvPr>
@@ -2797,7 +2797,7 @@
           <p:cNvPr id="8" name="">
             <a:extLst xmlns:a="http://schemas.openxmlformats.org/drawingml/2006/main">
               <a:ext uri="{FF2B5EF4-FFF2-40B4-BE49-F238E27FC236}">
-                <a16:creationId xmlns:a16="http://schemas.microsoft.com/office/drawing/2014/main" id="{DB5AE1F9-F7D9-4A17-9A56-7A4B33AF1917}"/>
+                <a16:creationId xmlns:a16="http://schemas.microsoft.com/office/drawing/2014/main" id="{34449F1F-8086-4F49-AABF-AE7A5A06CA93}"/>
               </a:ext>
             </a:extLst>
           </p:cNvPr>
@@ -2847,7 +2847,7 @@
           <p:cNvPr id="9" name="">
             <a:extLst xmlns:a="http://schemas.openxmlformats.org/drawingml/2006/main">
               <a:ext uri="{FF2B5EF4-FFF2-40B4-BE49-F238E27FC236}">
-                <a16:creationId xmlns:a16="http://schemas.microsoft.com/office/drawing/2014/main" id="{76A1F2CD-9CF2-4692-A994-81CCFD4ADAFD}"/>
+                <a16:creationId xmlns:a16="http://schemas.microsoft.com/office/drawing/2014/main" id="{AFC392E4-1523-48D9-937D-6B4C32747CD8}"/>
               </a:ext>
             </a:extLst>
           </p:cNvPr>
@@ -2914,7 +2914,7 @@
           <p:cNvPr id="10" name="">
             <a:extLst xmlns:a="http://schemas.openxmlformats.org/drawingml/2006/main">
               <a:ext uri="{FF2B5EF4-FFF2-40B4-BE49-F238E27FC236}">
-                <a16:creationId xmlns:a16="http://schemas.microsoft.com/office/drawing/2014/main" id="{6E1A031F-F574-4550-BF8B-6D680C2EDCBB}"/>
+                <a16:creationId xmlns:a16="http://schemas.microsoft.com/office/drawing/2014/main" id="{42DC5DA2-03AE-41BB-9938-DBAA025B2C9F}"/>
               </a:ext>
             </a:extLst>
           </p:cNvPr>
@@ -2964,7 +2964,7 @@
           <p:cNvPr id="11" name="">
             <a:extLst xmlns:a="http://schemas.openxmlformats.org/drawingml/2006/main">
               <a:ext uri="{FF2B5EF4-FFF2-40B4-BE49-F238E27FC236}">
-                <a16:creationId xmlns:a16="http://schemas.microsoft.com/office/drawing/2014/main" id="{15B16CB4-744D-4484-B66C-8A7F6A216DB2}"/>
+                <a16:creationId xmlns:a16="http://schemas.microsoft.com/office/drawing/2014/main" id="{437E2B59-7595-498F-A3AF-CB2D301D1AF5}"/>
               </a:ext>
             </a:extLst>
           </p:cNvPr>
@@ -3012,7 +3012,7 @@
     </p:spTree>
     <p:extLst>
       <p:ext uri="{BB962C8B-B14F-4D97-AF65-F5344CB8AC3E}">
-        <p14:creationId xmlns:p14="http://schemas.microsoft.com/office/powerpoint/2010/main" val="1960015845"/>
+        <p14:creationId xmlns:p14="http://schemas.microsoft.com/office/powerpoint/2010/main" val="222597100"/>
       </p:ext>
     </p:extLst>
   </p:cSld>
@@ -3043,7 +3043,7 @@
           <p:cNvPr id="23" name="">
             <a:extLst xmlns:a="http://schemas.openxmlformats.org/drawingml/2006/main">
               <a:ext uri="{FF2B5EF4-FFF2-40B4-BE49-F238E27FC236}">
-                <a16:creationId xmlns:a16="http://schemas.microsoft.com/office/drawing/2014/main" id="{6380D6E8-53A1-44BA-A82D-E1D6330D9D68}"/>
+                <a16:creationId xmlns:a16="http://schemas.microsoft.com/office/drawing/2014/main" id="{23C77DD4-66B5-411D-A06D-89279D759A72}"/>
               </a:ext>
             </a:extLst>
           </p:cNvPr>
@@ -3093,7 +3093,7 @@
           <p:cNvPr id="2" name="">
             <a:extLst xmlns:a="http://schemas.openxmlformats.org/drawingml/2006/main">
               <a:ext uri="{FF2B5EF4-FFF2-40B4-BE49-F238E27FC236}">
-                <a16:creationId xmlns:a16="http://schemas.microsoft.com/office/drawing/2014/main" id="{3645E0E0-F438-4801-9C2E-4C5AD273A604}"/>
+                <a16:creationId xmlns:a16="http://schemas.microsoft.com/office/drawing/2014/main" id="{A14F2A8C-E4D0-4F49-93E6-28D6409FF48B}"/>
               </a:ext>
             </a:extLst>
           </p:cNvPr>
@@ -3143,7 +3143,7 @@
           <p:cNvPr id="3" name="">
             <a:extLst xmlns:a="http://schemas.openxmlformats.org/drawingml/2006/main">
               <a:ext uri="{FF2B5EF4-FFF2-40B4-BE49-F238E27FC236}">
-                <a16:creationId xmlns:a16="http://schemas.microsoft.com/office/drawing/2014/main" id="{1BE745F5-C6ED-45B2-8B25-83FF585EF2FE}"/>
+                <a16:creationId xmlns:a16="http://schemas.microsoft.com/office/drawing/2014/main" id="{5B6F5D50-55F4-4421-B686-BD41FE54C105}"/>
               </a:ext>
             </a:extLst>
           </p:cNvPr>
@@ -3193,7 +3193,7 @@
           <p:cNvPr id="4" name="">
             <a:extLst xmlns:a="http://schemas.openxmlformats.org/drawingml/2006/main">
               <a:ext uri="{FF2B5EF4-FFF2-40B4-BE49-F238E27FC236}">
-                <a16:creationId xmlns:a16="http://schemas.microsoft.com/office/drawing/2014/main" id="{144D2C13-9EA6-4C89-B421-D9FEE2CC14CF}"/>
+                <a16:creationId xmlns:a16="http://schemas.microsoft.com/office/drawing/2014/main" id="{14777979-0E37-4F0C-9167-DE29388DE835}"/>
               </a:ext>
             </a:extLst>
           </p:cNvPr>
@@ -3243,7 +3243,7 @@
           <p:cNvPr id="5" name="">
             <a:extLst xmlns:a="http://schemas.openxmlformats.org/drawingml/2006/main">
               <a:ext uri="{FF2B5EF4-FFF2-40B4-BE49-F238E27FC236}">
-                <a16:creationId xmlns:a16="http://schemas.microsoft.com/office/drawing/2014/main" id="{1C38E51C-5501-427E-A527-745DF17FC48D}"/>
+                <a16:creationId xmlns:a16="http://schemas.microsoft.com/office/drawing/2014/main" id="{A483B7AA-4F5D-4422-8C04-4731BCE85FE9}"/>
               </a:ext>
             </a:extLst>
           </p:cNvPr>
@@ -3276,7 +3276,7 @@
           <p:cNvPr id="6" name="">
             <a:extLst xmlns:a="http://schemas.openxmlformats.org/drawingml/2006/main">
               <a:ext uri="{FF2B5EF4-FFF2-40B4-BE49-F238E27FC236}">
-                <a16:creationId xmlns:a16="http://schemas.microsoft.com/office/drawing/2014/main" id="{985A1352-940C-4B96-A6E6-1D2D5E3F6190}"/>
+                <a16:creationId xmlns:a16="http://schemas.microsoft.com/office/drawing/2014/main" id="{1D0ABECE-E0D9-4342-B515-905FDE76F178}"/>
               </a:ext>
             </a:extLst>
           </p:cNvPr>
@@ -3326,7 +3326,7 @@
           <p:cNvPr id="7" name="">
             <a:extLst xmlns:a="http://schemas.openxmlformats.org/drawingml/2006/main">
               <a:ext uri="{FF2B5EF4-FFF2-40B4-BE49-F238E27FC236}">
-                <a16:creationId xmlns:a16="http://schemas.microsoft.com/office/drawing/2014/main" id="{C5B43DF1-502C-4D7C-8D55-29A7220ECADD}"/>
+                <a16:creationId xmlns:a16="http://schemas.microsoft.com/office/drawing/2014/main" id="{40F5082B-EFF6-4A77-BCFA-196C3ED46EF7}"/>
               </a:ext>
             </a:extLst>
           </p:cNvPr>
@@ -3361,7 +3361,7 @@
           <p:cNvPr id="8" name="">
             <a:extLst xmlns:a="http://schemas.openxmlformats.org/drawingml/2006/main">
               <a:ext uri="{FF2B5EF4-FFF2-40B4-BE49-F238E27FC236}">
-                <a16:creationId xmlns:a16="http://schemas.microsoft.com/office/drawing/2014/main" id="{A2791FC8-8705-47E5-98A4-404210C2E090}"/>
+                <a16:creationId xmlns:a16="http://schemas.microsoft.com/office/drawing/2014/main" id="{82579DD3-8C33-40A0-A0FA-B0534DB7E749}"/>
               </a:ext>
             </a:extLst>
           </p:cNvPr>
@@ -3392,7 +3392,7 @@
           <p:cNvPr id="9" name="">
             <a:extLst xmlns:a="http://schemas.openxmlformats.org/drawingml/2006/main">
               <a:ext uri="{FF2B5EF4-FFF2-40B4-BE49-F238E27FC236}">
-                <a16:creationId xmlns:a16="http://schemas.microsoft.com/office/drawing/2014/main" id="{666802B1-A89A-4827-9B98-07D8EE8E0D3D}"/>
+                <a16:creationId xmlns:a16="http://schemas.microsoft.com/office/drawing/2014/main" id="{8FF4390A-19F8-49D9-B50C-DEF6F22F2FD7}"/>
               </a:ext>
             </a:extLst>
           </p:cNvPr>
@@ -3442,7 +3442,7 @@
           <p:cNvPr id="10" name="">
             <a:extLst xmlns:a="http://schemas.openxmlformats.org/drawingml/2006/main">
               <a:ext uri="{FF2B5EF4-FFF2-40B4-BE49-F238E27FC236}">
-                <a16:creationId xmlns:a16="http://schemas.microsoft.com/office/drawing/2014/main" id="{023354F7-51A3-42C6-B7FE-09B6077656C3}"/>
+                <a16:creationId xmlns:a16="http://schemas.microsoft.com/office/drawing/2014/main" id="{AE8669E8-6CC6-4408-971A-D9AB62702F5B}"/>
               </a:ext>
             </a:extLst>
           </p:cNvPr>
@@ -3492,7 +3492,7 @@
           <p:cNvPr id="11" name="">
             <a:extLst xmlns:a="http://schemas.openxmlformats.org/drawingml/2006/main">
               <a:ext uri="{FF2B5EF4-FFF2-40B4-BE49-F238E27FC236}">
-                <a16:creationId xmlns:a16="http://schemas.microsoft.com/office/drawing/2014/main" id="{FCC495A8-EF96-423D-8A8F-510CABE0A41A}"/>
+                <a16:creationId xmlns:a16="http://schemas.microsoft.com/office/drawing/2014/main" id="{6F7E4DEE-DDB2-492F-BC41-22B472C04B71}"/>
               </a:ext>
             </a:extLst>
           </p:cNvPr>
@@ -3527,7 +3527,7 @@
           <p:cNvPr id="12" name="">
             <a:extLst xmlns:a="http://schemas.openxmlformats.org/drawingml/2006/main">
               <a:ext uri="{FF2B5EF4-FFF2-40B4-BE49-F238E27FC236}">
-                <a16:creationId xmlns:a16="http://schemas.microsoft.com/office/drawing/2014/main" id="{FCD6A72F-8F55-4BCB-A668-5D5972C2D65D}"/>
+                <a16:creationId xmlns:a16="http://schemas.microsoft.com/office/drawing/2014/main" id="{DA47A09A-8449-44A9-BCDB-BD14CC930477}"/>
               </a:ext>
             </a:extLst>
           </p:cNvPr>
@@ -3558,7 +3558,7 @@
           <p:cNvPr id="13" name="">
             <a:extLst xmlns:a="http://schemas.openxmlformats.org/drawingml/2006/main">
               <a:ext uri="{FF2B5EF4-FFF2-40B4-BE49-F238E27FC236}">
-                <a16:creationId xmlns:a16="http://schemas.microsoft.com/office/drawing/2014/main" id="{535DEE81-AB13-48A9-933A-B40D68AAD84D}"/>
+                <a16:creationId xmlns:a16="http://schemas.microsoft.com/office/drawing/2014/main" id="{835C50A1-E258-478E-9489-0E1F6ADF44C1}"/>
               </a:ext>
             </a:extLst>
           </p:cNvPr>
@@ -3608,7 +3608,7 @@
           <p:cNvPr id="14" name="">
             <a:extLst xmlns:a="http://schemas.openxmlformats.org/drawingml/2006/main">
               <a:ext uri="{FF2B5EF4-FFF2-40B4-BE49-F238E27FC236}">
-                <a16:creationId xmlns:a16="http://schemas.microsoft.com/office/drawing/2014/main" id="{00B1AB2C-B24F-40CD-973C-62DC5F8450E4}"/>
+                <a16:creationId xmlns:a16="http://schemas.microsoft.com/office/drawing/2014/main" id="{880243FF-DB18-4356-8BBA-338A13D2C070}"/>
               </a:ext>
             </a:extLst>
           </p:cNvPr>
@@ -3658,7 +3658,7 @@
           <p:cNvPr id="15" name="">
             <a:extLst xmlns:a="http://schemas.openxmlformats.org/drawingml/2006/main">
               <a:ext uri="{FF2B5EF4-FFF2-40B4-BE49-F238E27FC236}">
-                <a16:creationId xmlns:a16="http://schemas.microsoft.com/office/drawing/2014/main" id="{CD7730D1-97BD-4F6C-B201-8DB5633595D7}"/>
+                <a16:creationId xmlns:a16="http://schemas.microsoft.com/office/drawing/2014/main" id="{C4210F0B-580D-429D-A0E9-D0AEAA146F08}"/>
               </a:ext>
             </a:extLst>
           </p:cNvPr>
@@ -3693,7 +3693,7 @@
           <p:cNvPr id="16" name="">
             <a:extLst xmlns:a="http://schemas.openxmlformats.org/drawingml/2006/main">
               <a:ext uri="{FF2B5EF4-FFF2-40B4-BE49-F238E27FC236}">
-                <a16:creationId xmlns:a16="http://schemas.microsoft.com/office/drawing/2014/main" id="{C9BC34B7-A9EE-47E5-844E-C3FFA72D949D}"/>
+                <a16:creationId xmlns:a16="http://schemas.microsoft.com/office/drawing/2014/main" id="{162F7A03-6FDF-463D-8D75-EA767146144C}"/>
               </a:ext>
             </a:extLst>
           </p:cNvPr>
@@ -3724,7 +3724,7 @@
           <p:cNvPr id="17" name="">
             <a:extLst xmlns:a="http://schemas.openxmlformats.org/drawingml/2006/main">
               <a:ext uri="{FF2B5EF4-FFF2-40B4-BE49-F238E27FC236}">
-                <a16:creationId xmlns:a16="http://schemas.microsoft.com/office/drawing/2014/main" id="{51E3B415-43D8-4B6F-82AF-2A8FD7FACD77}"/>
+                <a16:creationId xmlns:a16="http://schemas.microsoft.com/office/drawing/2014/main" id="{8F7328E2-BD78-4D80-BEDB-BE8CC4A0CB1D}"/>
               </a:ext>
             </a:extLst>
           </p:cNvPr>
@@ -3774,7 +3774,7 @@
           <p:cNvPr id="18" name="">
             <a:extLst xmlns:a="http://schemas.openxmlformats.org/drawingml/2006/main">
               <a:ext uri="{FF2B5EF4-FFF2-40B4-BE49-F238E27FC236}">
-                <a16:creationId xmlns:a16="http://schemas.microsoft.com/office/drawing/2014/main" id="{6A57BFC7-4335-43FC-BACE-0B31810C9382}"/>
+                <a16:creationId xmlns:a16="http://schemas.microsoft.com/office/drawing/2014/main" id="{87EDDB75-7C68-4FDD-9FBA-1E33ADE9968F}"/>
               </a:ext>
             </a:extLst>
           </p:cNvPr>
@@ -3824,7 +3824,7 @@
           <p:cNvPr id="19" name="">
             <a:extLst xmlns:a="http://schemas.openxmlformats.org/drawingml/2006/main">
               <a:ext uri="{FF2B5EF4-FFF2-40B4-BE49-F238E27FC236}">
-                <a16:creationId xmlns:a16="http://schemas.microsoft.com/office/drawing/2014/main" id="{2C1AD88B-9994-4AAA-B818-F9D8FF9CEBEA}"/>
+                <a16:creationId xmlns:a16="http://schemas.microsoft.com/office/drawing/2014/main" id="{9A5B48DE-2242-41D0-AF58-653731FA3AFE}"/>
               </a:ext>
             </a:extLst>
           </p:cNvPr>
@@ -3859,7 +3859,7 @@
           <p:cNvPr id="20" name="">
             <a:extLst xmlns:a="http://schemas.openxmlformats.org/drawingml/2006/main">
               <a:ext uri="{FF2B5EF4-FFF2-40B4-BE49-F238E27FC236}">
-                <a16:creationId xmlns:a16="http://schemas.microsoft.com/office/drawing/2014/main" id="{7A48C94A-BCD8-4B55-BBBA-D699949D541D}"/>
+                <a16:creationId xmlns:a16="http://schemas.microsoft.com/office/drawing/2014/main" id="{AF1FFA00-7F4B-43B8-9742-729CF25F5035}"/>
               </a:ext>
             </a:extLst>
           </p:cNvPr>
@@ -3890,7 +3890,7 @@
           <p:cNvPr id="21" name="">
             <a:extLst xmlns:a="http://schemas.openxmlformats.org/drawingml/2006/main">
               <a:ext uri="{FF2B5EF4-FFF2-40B4-BE49-F238E27FC236}">
-                <a16:creationId xmlns:a16="http://schemas.microsoft.com/office/drawing/2014/main" id="{97F365A3-97A0-448C-9807-8B7EA6AC8898}"/>
+                <a16:creationId xmlns:a16="http://schemas.microsoft.com/office/drawing/2014/main" id="{6FE043D8-472A-48DA-B322-6D7C1CFCD86E}"/>
               </a:ext>
             </a:extLst>
           </p:cNvPr>
@@ -3940,7 +3940,7 @@
           <p:cNvPr id="22" name="">
             <a:extLst xmlns:a="http://schemas.openxmlformats.org/drawingml/2006/main">
               <a:ext uri="{FF2B5EF4-FFF2-40B4-BE49-F238E27FC236}">
-                <a16:creationId xmlns:a16="http://schemas.microsoft.com/office/drawing/2014/main" id="{150C6033-B883-4CC9-990D-8BF62D766641}"/>
+                <a16:creationId xmlns:a16="http://schemas.microsoft.com/office/drawing/2014/main" id="{FC4A2274-9486-4E3D-8F6E-728A2F5713CB}"/>
               </a:ext>
             </a:extLst>
           </p:cNvPr>
@@ -3988,7 +3988,7 @@
     </p:spTree>
     <p:extLst>
       <p:ext uri="{BB962C8B-B14F-4D97-AF65-F5344CB8AC3E}">
-        <p14:creationId xmlns:p14="http://schemas.microsoft.com/office/powerpoint/2010/main" val="1628870172"/>
+        <p14:creationId xmlns:p14="http://schemas.microsoft.com/office/powerpoint/2010/main" val="1408556067"/>
       </p:ext>
     </p:extLst>
   </p:cSld>
@@ -4019,7 +4019,7 @@
           <p:cNvPr id="23" name="">
             <a:extLst xmlns:a="http://schemas.openxmlformats.org/drawingml/2006/main">
               <a:ext uri="{FF2B5EF4-FFF2-40B4-BE49-F238E27FC236}">
-                <a16:creationId xmlns:a16="http://schemas.microsoft.com/office/drawing/2014/main" id="{32C4EA02-7D75-45BA-91E3-C3E982C0F40C}"/>
+                <a16:creationId xmlns:a16="http://schemas.microsoft.com/office/drawing/2014/main" id="{AE401161-F0C0-4650-9366-2CAF079E2B27}"/>
               </a:ext>
             </a:extLst>
           </p:cNvPr>
@@ -4069,7 +4069,7 @@
           <p:cNvPr id="2" name="">
             <a:extLst xmlns:a="http://schemas.openxmlformats.org/drawingml/2006/main">
               <a:ext uri="{FF2B5EF4-FFF2-40B4-BE49-F238E27FC236}">
-                <a16:creationId xmlns:a16="http://schemas.microsoft.com/office/drawing/2014/main" id="{92D93F5C-19E6-4F20-9F6C-CC9643C26F67}"/>
+                <a16:creationId xmlns:a16="http://schemas.microsoft.com/office/drawing/2014/main" id="{77A97CB7-4C37-4F9E-8F3D-B4B7D3DE852F}"/>
               </a:ext>
             </a:extLst>
           </p:cNvPr>
@@ -4119,7 +4119,7 @@
           <p:cNvPr id="3" name="">
             <a:extLst xmlns:a="http://schemas.openxmlformats.org/drawingml/2006/main">
               <a:ext uri="{FF2B5EF4-FFF2-40B4-BE49-F238E27FC236}">
-                <a16:creationId xmlns:a16="http://schemas.microsoft.com/office/drawing/2014/main" id="{0CCE8482-3F28-4B25-B463-35CA9C11D849}"/>
+                <a16:creationId xmlns:a16="http://schemas.microsoft.com/office/drawing/2014/main" id="{DEE5E36F-4500-4091-B0FC-2C29E4B0B0AB}"/>
               </a:ext>
             </a:extLst>
           </p:cNvPr>
@@ -4169,7 +4169,7 @@
           <p:cNvPr id="4" name="">
             <a:extLst xmlns:a="http://schemas.openxmlformats.org/drawingml/2006/main">
               <a:ext uri="{FF2B5EF4-FFF2-40B4-BE49-F238E27FC236}">
-                <a16:creationId xmlns:a16="http://schemas.microsoft.com/office/drawing/2014/main" id="{4CBC6557-BFC6-459C-B266-39CEB174E2E5}"/>
+                <a16:creationId xmlns:a16="http://schemas.microsoft.com/office/drawing/2014/main" id="{048FA05E-5959-4CA0-B0D5-D142A38C3A8F}"/>
               </a:ext>
             </a:extLst>
           </p:cNvPr>
@@ -4219,7 +4219,7 @@
           <p:cNvPr id="5" name="">
             <a:extLst xmlns:a="http://schemas.openxmlformats.org/drawingml/2006/main">
               <a:ext uri="{FF2B5EF4-FFF2-40B4-BE49-F238E27FC236}">
-                <a16:creationId xmlns:a16="http://schemas.microsoft.com/office/drawing/2014/main" id="{EED747E6-B450-40F4-A848-FBBB99E22AA8}"/>
+                <a16:creationId xmlns:a16="http://schemas.microsoft.com/office/drawing/2014/main" id="{449C855E-A624-4371-A7AD-F4A5C498FCBE}"/>
               </a:ext>
             </a:extLst>
           </p:cNvPr>
@@ -4252,7 +4252,7 @@
           <p:cNvPr id="6" name="">
             <a:extLst xmlns:a="http://schemas.openxmlformats.org/drawingml/2006/main">
               <a:ext uri="{FF2B5EF4-FFF2-40B4-BE49-F238E27FC236}">
-                <a16:creationId xmlns:a16="http://schemas.microsoft.com/office/drawing/2014/main" id="{10A5F02F-21E1-46AE-A033-EEA433CB12C7}"/>
+                <a16:creationId xmlns:a16="http://schemas.microsoft.com/office/drawing/2014/main" id="{424369CC-7DB6-437F-8E0E-3EE888F19954}"/>
               </a:ext>
             </a:extLst>
           </p:cNvPr>
@@ -4302,7 +4302,7 @@
           <p:cNvPr id="7" name="">
             <a:extLst xmlns:a="http://schemas.openxmlformats.org/drawingml/2006/main">
               <a:ext uri="{FF2B5EF4-FFF2-40B4-BE49-F238E27FC236}">
-                <a16:creationId xmlns:a16="http://schemas.microsoft.com/office/drawing/2014/main" id="{2B03B5F6-53F5-42D3-8734-48C7BF26378B}"/>
+                <a16:creationId xmlns:a16="http://schemas.microsoft.com/office/drawing/2014/main" id="{2DE0F5D8-B527-4BA3-9E0C-4C2F04118844}"/>
               </a:ext>
             </a:extLst>
           </p:cNvPr>
@@ -4337,7 +4337,7 @@
           <p:cNvPr id="8" name="">
             <a:extLst xmlns:a="http://schemas.openxmlformats.org/drawingml/2006/main">
               <a:ext uri="{FF2B5EF4-FFF2-40B4-BE49-F238E27FC236}">
-                <a16:creationId xmlns:a16="http://schemas.microsoft.com/office/drawing/2014/main" id="{F295C6AD-402E-495C-8FCB-90615CBD0C45}"/>
+                <a16:creationId xmlns:a16="http://schemas.microsoft.com/office/drawing/2014/main" id="{4884CC42-6877-4337-93C5-907DA2E46375}"/>
               </a:ext>
             </a:extLst>
           </p:cNvPr>
@@ -4368,7 +4368,7 @@
           <p:cNvPr id="9" name="">
             <a:extLst xmlns:a="http://schemas.openxmlformats.org/drawingml/2006/main">
               <a:ext uri="{FF2B5EF4-FFF2-40B4-BE49-F238E27FC236}">
-                <a16:creationId xmlns:a16="http://schemas.microsoft.com/office/drawing/2014/main" id="{422EF38B-BE62-4F22-9A10-A2DE7B929ACE}"/>
+                <a16:creationId xmlns:a16="http://schemas.microsoft.com/office/drawing/2014/main" id="{FD6967EE-DE89-4D41-A8A2-E3BEE50D0626}"/>
               </a:ext>
             </a:extLst>
           </p:cNvPr>
@@ -4418,7 +4418,7 @@
           <p:cNvPr id="10" name="">
             <a:extLst xmlns:a="http://schemas.openxmlformats.org/drawingml/2006/main">
               <a:ext uri="{FF2B5EF4-FFF2-40B4-BE49-F238E27FC236}">
-                <a16:creationId xmlns:a16="http://schemas.microsoft.com/office/drawing/2014/main" id="{5A1EBDAA-DB11-48AA-BF00-BB5BE32173A3}"/>
+                <a16:creationId xmlns:a16="http://schemas.microsoft.com/office/drawing/2014/main" id="{C232FEB2-A1D8-4657-AD51-01332A2BB60D}"/>
               </a:ext>
             </a:extLst>
           </p:cNvPr>
@@ -4468,7 +4468,7 @@
           <p:cNvPr id="11" name="">
             <a:extLst xmlns:a="http://schemas.openxmlformats.org/drawingml/2006/main">
               <a:ext uri="{FF2B5EF4-FFF2-40B4-BE49-F238E27FC236}">
-                <a16:creationId xmlns:a16="http://schemas.microsoft.com/office/drawing/2014/main" id="{40EA98E9-BE9F-49BF-8941-33A28DBA8F6F}"/>
+                <a16:creationId xmlns:a16="http://schemas.microsoft.com/office/drawing/2014/main" id="{89EC056F-D14D-44F6-922F-3E216D5D0547}"/>
               </a:ext>
             </a:extLst>
           </p:cNvPr>
@@ -4503,7 +4503,7 @@
           <p:cNvPr id="12" name="">
             <a:extLst xmlns:a="http://schemas.openxmlformats.org/drawingml/2006/main">
               <a:ext uri="{FF2B5EF4-FFF2-40B4-BE49-F238E27FC236}">
-                <a16:creationId xmlns:a16="http://schemas.microsoft.com/office/drawing/2014/main" id="{91117CC3-7A72-4ABC-8F42-EEEDB9382542}"/>
+                <a16:creationId xmlns:a16="http://schemas.microsoft.com/office/drawing/2014/main" id="{98BF0F9F-EBD9-4CD6-A696-053481E9AEE2}"/>
               </a:ext>
             </a:extLst>
           </p:cNvPr>
@@ -4534,7 +4534,7 @@
           <p:cNvPr id="13" name="">
             <a:extLst xmlns:a="http://schemas.openxmlformats.org/drawingml/2006/main">
               <a:ext uri="{FF2B5EF4-FFF2-40B4-BE49-F238E27FC236}">
-                <a16:creationId xmlns:a16="http://schemas.microsoft.com/office/drawing/2014/main" id="{AC5ADF0E-51CD-45C3-958E-31AEB3E80D71}"/>
+                <a16:creationId xmlns:a16="http://schemas.microsoft.com/office/drawing/2014/main" id="{26444AD5-2023-4DBA-B47D-F5870BC9334C}"/>
               </a:ext>
             </a:extLst>
           </p:cNvPr>
@@ -4584,7 +4584,7 @@
           <p:cNvPr id="14" name="">
             <a:extLst xmlns:a="http://schemas.openxmlformats.org/drawingml/2006/main">
               <a:ext uri="{FF2B5EF4-FFF2-40B4-BE49-F238E27FC236}">
-                <a16:creationId xmlns:a16="http://schemas.microsoft.com/office/drawing/2014/main" id="{B68F2E48-1636-4DF6-B1A7-6FB53A9BD7A9}"/>
+                <a16:creationId xmlns:a16="http://schemas.microsoft.com/office/drawing/2014/main" id="{4347681E-19D8-421E-AADF-6AA6A679B3A8}"/>
               </a:ext>
             </a:extLst>
           </p:cNvPr>
@@ -4634,7 +4634,7 @@
           <p:cNvPr id="15" name="">
             <a:extLst xmlns:a="http://schemas.openxmlformats.org/drawingml/2006/main">
               <a:ext uri="{FF2B5EF4-FFF2-40B4-BE49-F238E27FC236}">
-                <a16:creationId xmlns:a16="http://schemas.microsoft.com/office/drawing/2014/main" id="{24687125-9DFE-462C-9521-02F8F7D922B9}"/>
+                <a16:creationId xmlns:a16="http://schemas.microsoft.com/office/drawing/2014/main" id="{FA001F8B-E0BA-4C27-ABD9-0EC4EAB3C454}"/>
               </a:ext>
             </a:extLst>
           </p:cNvPr>
@@ -4669,7 +4669,7 @@
           <p:cNvPr id="16" name="">
             <a:extLst xmlns:a="http://schemas.openxmlformats.org/drawingml/2006/main">
               <a:ext uri="{FF2B5EF4-FFF2-40B4-BE49-F238E27FC236}">
-                <a16:creationId xmlns:a16="http://schemas.microsoft.com/office/drawing/2014/main" id="{5BDAA173-6F32-4EEF-A61C-1C4FDB69570E}"/>
+                <a16:creationId xmlns:a16="http://schemas.microsoft.com/office/drawing/2014/main" id="{5485808F-A55F-4F56-BA4D-BF8889B5F8F2}"/>
               </a:ext>
             </a:extLst>
           </p:cNvPr>
@@ -4700,7 +4700,7 @@
           <p:cNvPr id="17" name="">
             <a:extLst xmlns:a="http://schemas.openxmlformats.org/drawingml/2006/main">
               <a:ext uri="{FF2B5EF4-FFF2-40B4-BE49-F238E27FC236}">
-                <a16:creationId xmlns:a16="http://schemas.microsoft.com/office/drawing/2014/main" id="{894885FA-DDA5-4F73-B117-1CC540AD8342}"/>
+                <a16:creationId xmlns:a16="http://schemas.microsoft.com/office/drawing/2014/main" id="{AB2C34AD-2D86-4EA5-9BCD-8B1BC87985DA}"/>
               </a:ext>
             </a:extLst>
           </p:cNvPr>
@@ -4750,7 +4750,7 @@
           <p:cNvPr id="18" name="">
             <a:extLst xmlns:a="http://schemas.openxmlformats.org/drawingml/2006/main">
               <a:ext uri="{FF2B5EF4-FFF2-40B4-BE49-F238E27FC236}">
-                <a16:creationId xmlns:a16="http://schemas.microsoft.com/office/drawing/2014/main" id="{45FEECFB-AAB0-43AA-ACFD-97DC85591EE2}"/>
+                <a16:creationId xmlns:a16="http://schemas.microsoft.com/office/drawing/2014/main" id="{3D9614C1-1988-4E1B-9C6B-B02F5BA65C3F}"/>
               </a:ext>
             </a:extLst>
           </p:cNvPr>
@@ -4800,7 +4800,7 @@
           <p:cNvPr id="19" name="">
             <a:extLst xmlns:a="http://schemas.openxmlformats.org/drawingml/2006/main">
               <a:ext uri="{FF2B5EF4-FFF2-40B4-BE49-F238E27FC236}">
-                <a16:creationId xmlns:a16="http://schemas.microsoft.com/office/drawing/2014/main" id="{DA593401-716B-49A4-9388-3E81E4D5BE36}"/>
+                <a16:creationId xmlns:a16="http://schemas.microsoft.com/office/drawing/2014/main" id="{76E339B2-C342-4CF7-9E5D-CA1F145F7F56}"/>
               </a:ext>
             </a:extLst>
           </p:cNvPr>
@@ -4835,7 +4835,7 @@
           <p:cNvPr id="20" name="">
             <a:extLst xmlns:a="http://schemas.openxmlformats.org/drawingml/2006/main">
               <a:ext uri="{FF2B5EF4-FFF2-40B4-BE49-F238E27FC236}">
-                <a16:creationId xmlns:a16="http://schemas.microsoft.com/office/drawing/2014/main" id="{D3D60548-E07E-4182-98C8-78EE973BE796}"/>
+                <a16:creationId xmlns:a16="http://schemas.microsoft.com/office/drawing/2014/main" id="{8066DB9E-1B7D-4EB4-AD9B-F9C87828D09C}"/>
               </a:ext>
             </a:extLst>
           </p:cNvPr>
@@ -4866,7 +4866,7 @@
           <p:cNvPr id="21" name="">
             <a:extLst xmlns:a="http://schemas.openxmlformats.org/drawingml/2006/main">
               <a:ext uri="{FF2B5EF4-FFF2-40B4-BE49-F238E27FC236}">
-                <a16:creationId xmlns:a16="http://schemas.microsoft.com/office/drawing/2014/main" id="{A6ECECBF-BA5C-42F7-AA7F-AA99135A526B}"/>
+                <a16:creationId xmlns:a16="http://schemas.microsoft.com/office/drawing/2014/main" id="{5A1EDB16-E7E6-4CB0-B043-2F891A1B690A}"/>
               </a:ext>
             </a:extLst>
           </p:cNvPr>
@@ -4916,7 +4916,7 @@
           <p:cNvPr id="22" name="">
             <a:extLst xmlns:a="http://schemas.openxmlformats.org/drawingml/2006/main">
               <a:ext uri="{FF2B5EF4-FFF2-40B4-BE49-F238E27FC236}">
-                <a16:creationId xmlns:a16="http://schemas.microsoft.com/office/drawing/2014/main" id="{4242764E-D884-4E9D-B8FA-0A9B68CA94AF}"/>
+                <a16:creationId xmlns:a16="http://schemas.microsoft.com/office/drawing/2014/main" id="{B076F39F-4B02-41D0-A86A-37D8E7355A31}"/>
               </a:ext>
             </a:extLst>
           </p:cNvPr>
@@ -4964,7 +4964,7 @@
     </p:spTree>
     <p:extLst>
       <p:ext uri="{BB962C8B-B14F-4D97-AF65-F5344CB8AC3E}">
-        <p14:creationId xmlns:p14="http://schemas.microsoft.com/office/powerpoint/2010/main" val="1319585149"/>
+        <p14:creationId xmlns:p14="http://schemas.microsoft.com/office/powerpoint/2010/main" val="421068750"/>
       </p:ext>
     </p:extLst>
   </p:cSld>
@@ -4995,7 +4995,7 @@
           <p:cNvPr id="23" name="">
             <a:extLst xmlns:a="http://schemas.openxmlformats.org/drawingml/2006/main">
               <a:ext uri="{FF2B5EF4-FFF2-40B4-BE49-F238E27FC236}">
-                <a16:creationId xmlns:a16="http://schemas.microsoft.com/office/drawing/2014/main" id="{61505591-52BC-439D-A423-653451B60381}"/>
+                <a16:creationId xmlns:a16="http://schemas.microsoft.com/office/drawing/2014/main" id="{8C169CD3-D585-4D1F-A336-B5900ACB1164}"/>
               </a:ext>
             </a:extLst>
           </p:cNvPr>
@@ -5045,7 +5045,7 @@
           <p:cNvPr id="2" name="">
             <a:extLst xmlns:a="http://schemas.openxmlformats.org/drawingml/2006/main">
               <a:ext uri="{FF2B5EF4-FFF2-40B4-BE49-F238E27FC236}">
-                <a16:creationId xmlns:a16="http://schemas.microsoft.com/office/drawing/2014/main" id="{DFAA6578-5619-422D-80C5-404565324B53}"/>
+                <a16:creationId xmlns:a16="http://schemas.microsoft.com/office/drawing/2014/main" id="{59854383-54C4-410A-BA2F-73CB529E822E}"/>
               </a:ext>
             </a:extLst>
           </p:cNvPr>
@@ -5095,7 +5095,7 @@
           <p:cNvPr id="3" name="">
             <a:extLst xmlns:a="http://schemas.openxmlformats.org/drawingml/2006/main">
               <a:ext uri="{FF2B5EF4-FFF2-40B4-BE49-F238E27FC236}">
-                <a16:creationId xmlns:a16="http://schemas.microsoft.com/office/drawing/2014/main" id="{4F607797-126B-4CCA-B3F6-283FD7790325}"/>
+                <a16:creationId xmlns:a16="http://schemas.microsoft.com/office/drawing/2014/main" id="{5ED01F93-1C20-4402-8D73-1C1E624C84FD}"/>
               </a:ext>
             </a:extLst>
           </p:cNvPr>
@@ -5145,7 +5145,7 @@
           <p:cNvPr id="4" name="">
             <a:extLst xmlns:a="http://schemas.openxmlformats.org/drawingml/2006/main">
               <a:ext uri="{FF2B5EF4-FFF2-40B4-BE49-F238E27FC236}">
-                <a16:creationId xmlns:a16="http://schemas.microsoft.com/office/drawing/2014/main" id="{CAC0B2A1-3272-48AE-9FAA-B9B766793381}"/>
+                <a16:creationId xmlns:a16="http://schemas.microsoft.com/office/drawing/2014/main" id="{2EFC1207-434E-4F9C-B217-F5B3C6E2890E}"/>
               </a:ext>
             </a:extLst>
           </p:cNvPr>
@@ -5195,7 +5195,7 @@
           <p:cNvPr id="5" name="">
             <a:extLst xmlns:a="http://schemas.openxmlformats.org/drawingml/2006/main">
               <a:ext uri="{FF2B5EF4-FFF2-40B4-BE49-F238E27FC236}">
-                <a16:creationId xmlns:a16="http://schemas.microsoft.com/office/drawing/2014/main" id="{CE750E65-18AC-4E6A-B054-ED7979D7F2CD}"/>
+                <a16:creationId xmlns:a16="http://schemas.microsoft.com/office/drawing/2014/main" id="{933C0ACB-DE73-41D1-81AE-0309330632F3}"/>
               </a:ext>
             </a:extLst>
           </p:cNvPr>
@@ -5228,7 +5228,7 @@
           <p:cNvPr id="6" name="">
             <a:extLst xmlns:a="http://schemas.openxmlformats.org/drawingml/2006/main">
               <a:ext uri="{FF2B5EF4-FFF2-40B4-BE49-F238E27FC236}">
-                <a16:creationId xmlns:a16="http://schemas.microsoft.com/office/drawing/2014/main" id="{578905CD-7144-46C2-B6A6-85A3B23340F9}"/>
+                <a16:creationId xmlns:a16="http://schemas.microsoft.com/office/drawing/2014/main" id="{B8959B03-822B-4143-8AD3-34004D1D63B4}"/>
               </a:ext>
             </a:extLst>
           </p:cNvPr>
@@ -5278,7 +5278,7 @@
           <p:cNvPr id="7" name="">
             <a:extLst xmlns:a="http://schemas.openxmlformats.org/drawingml/2006/main">
               <a:ext uri="{FF2B5EF4-FFF2-40B4-BE49-F238E27FC236}">
-                <a16:creationId xmlns:a16="http://schemas.microsoft.com/office/drawing/2014/main" id="{6F6D8E24-0135-4E85-8651-41E690868411}"/>
+                <a16:creationId xmlns:a16="http://schemas.microsoft.com/office/drawing/2014/main" id="{A69BD018-9124-4C55-AB51-633C30D75AFD}"/>
               </a:ext>
             </a:extLst>
           </p:cNvPr>
@@ -5313,7 +5313,7 @@
           <p:cNvPr id="8" name="">
             <a:extLst xmlns:a="http://schemas.openxmlformats.org/drawingml/2006/main">
               <a:ext uri="{FF2B5EF4-FFF2-40B4-BE49-F238E27FC236}">
-                <a16:creationId xmlns:a16="http://schemas.microsoft.com/office/drawing/2014/main" id="{FF556DD7-6D1A-4305-B722-E7F442CC0807}"/>
+                <a16:creationId xmlns:a16="http://schemas.microsoft.com/office/drawing/2014/main" id="{CD718F84-99E4-4AA5-B7CB-0BC774DDD384}"/>
               </a:ext>
             </a:extLst>
           </p:cNvPr>
@@ -5344,7 +5344,7 @@
           <p:cNvPr id="9" name="">
             <a:extLst xmlns:a="http://schemas.openxmlformats.org/drawingml/2006/main">
               <a:ext uri="{FF2B5EF4-FFF2-40B4-BE49-F238E27FC236}">
-                <a16:creationId xmlns:a16="http://schemas.microsoft.com/office/drawing/2014/main" id="{FCB51E2F-1DFA-4CAC-94ED-4580B34BEA97}"/>
+                <a16:creationId xmlns:a16="http://schemas.microsoft.com/office/drawing/2014/main" id="{1DD75F21-EBB9-480B-8BEA-6C9D1C08C8A8}"/>
               </a:ext>
             </a:extLst>
           </p:cNvPr>
@@ -5394,7 +5394,7 @@
           <p:cNvPr id="10" name="">
             <a:extLst xmlns:a="http://schemas.openxmlformats.org/drawingml/2006/main">
               <a:ext uri="{FF2B5EF4-FFF2-40B4-BE49-F238E27FC236}">
-                <a16:creationId xmlns:a16="http://schemas.microsoft.com/office/drawing/2014/main" id="{BF4CD4DE-041A-4822-80C7-ACB70F252357}"/>
+                <a16:creationId xmlns:a16="http://schemas.microsoft.com/office/drawing/2014/main" id="{0D142525-01D7-4C6F-87DD-9A910777E69E}"/>
               </a:ext>
             </a:extLst>
           </p:cNvPr>
@@ -5444,7 +5444,7 @@
           <p:cNvPr id="11" name="">
             <a:extLst xmlns:a="http://schemas.openxmlformats.org/drawingml/2006/main">
               <a:ext uri="{FF2B5EF4-FFF2-40B4-BE49-F238E27FC236}">
-                <a16:creationId xmlns:a16="http://schemas.microsoft.com/office/drawing/2014/main" id="{FC1F9384-289C-49D9-BFE2-951A2AEDF01B}"/>
+                <a16:creationId xmlns:a16="http://schemas.microsoft.com/office/drawing/2014/main" id="{9B89FE07-6160-4371-BD97-DD59328D5577}"/>
               </a:ext>
             </a:extLst>
           </p:cNvPr>
@@ -5479,7 +5479,7 @@
           <p:cNvPr id="12" name="">
             <a:extLst xmlns:a="http://schemas.openxmlformats.org/drawingml/2006/main">
               <a:ext uri="{FF2B5EF4-FFF2-40B4-BE49-F238E27FC236}">
-                <a16:creationId xmlns:a16="http://schemas.microsoft.com/office/drawing/2014/main" id="{4FA49E50-32E0-4E4B-8B55-E43455B8776C}"/>
+                <a16:creationId xmlns:a16="http://schemas.microsoft.com/office/drawing/2014/main" id="{052EDE1D-9933-4F62-B2DB-00D21E1898DF}"/>
               </a:ext>
             </a:extLst>
           </p:cNvPr>
@@ -5510,7 +5510,7 @@
           <p:cNvPr id="13" name="">
             <a:extLst xmlns:a="http://schemas.openxmlformats.org/drawingml/2006/main">
               <a:ext uri="{FF2B5EF4-FFF2-40B4-BE49-F238E27FC236}">
-                <a16:creationId xmlns:a16="http://schemas.microsoft.com/office/drawing/2014/main" id="{9EF99131-5321-4318-8E1C-9AB4E01BC9AB}"/>
+                <a16:creationId xmlns:a16="http://schemas.microsoft.com/office/drawing/2014/main" id="{9C51C4B4-A342-4C22-AB81-1721B2B7775E}"/>
               </a:ext>
             </a:extLst>
           </p:cNvPr>
@@ -5560,7 +5560,7 @@
           <p:cNvPr id="14" name="">
             <a:extLst xmlns:a="http://schemas.openxmlformats.org/drawingml/2006/main">
               <a:ext uri="{FF2B5EF4-FFF2-40B4-BE49-F238E27FC236}">
-                <a16:creationId xmlns:a16="http://schemas.microsoft.com/office/drawing/2014/main" id="{69B7201C-22E7-4650-BF24-7539924655F5}"/>
+                <a16:creationId xmlns:a16="http://schemas.microsoft.com/office/drawing/2014/main" id="{92F4D027-9AAB-420C-A19E-1F5F8145F51B}"/>
               </a:ext>
             </a:extLst>
           </p:cNvPr>
@@ -5610,7 +5610,7 @@
           <p:cNvPr id="15" name="">
             <a:extLst xmlns:a="http://schemas.openxmlformats.org/drawingml/2006/main">
               <a:ext uri="{FF2B5EF4-FFF2-40B4-BE49-F238E27FC236}">
-                <a16:creationId xmlns:a16="http://schemas.microsoft.com/office/drawing/2014/main" id="{111EA923-3ED0-48BC-B51E-3864CF0C8877}"/>
+                <a16:creationId xmlns:a16="http://schemas.microsoft.com/office/drawing/2014/main" id="{20C436C0-A39A-48FB-8FA9-3A4D821D862E}"/>
               </a:ext>
             </a:extLst>
           </p:cNvPr>
@@ -5645,7 +5645,7 @@
           <p:cNvPr id="16" name="">
             <a:extLst xmlns:a="http://schemas.openxmlformats.org/drawingml/2006/main">
               <a:ext uri="{FF2B5EF4-FFF2-40B4-BE49-F238E27FC236}">
-                <a16:creationId xmlns:a16="http://schemas.microsoft.com/office/drawing/2014/main" id="{03B4FCD6-7845-4EAE-9282-D35CF547D007}"/>
+                <a16:creationId xmlns:a16="http://schemas.microsoft.com/office/drawing/2014/main" id="{2DF08C7D-0101-40C5-BCF6-0EE8DC9484AE}"/>
               </a:ext>
             </a:extLst>
           </p:cNvPr>
@@ -5676,7 +5676,7 @@
           <p:cNvPr id="17" name="">
             <a:extLst xmlns:a="http://schemas.openxmlformats.org/drawingml/2006/main">
               <a:ext uri="{FF2B5EF4-FFF2-40B4-BE49-F238E27FC236}">
-                <a16:creationId xmlns:a16="http://schemas.microsoft.com/office/drawing/2014/main" id="{189189E2-1BDD-4459-9EDD-03E345258557}"/>
+                <a16:creationId xmlns:a16="http://schemas.microsoft.com/office/drawing/2014/main" id="{9676BB43-0E84-4C83-AE3B-9B748436593B}"/>
               </a:ext>
             </a:extLst>
           </p:cNvPr>
@@ -5726,7 +5726,7 @@
           <p:cNvPr id="18" name="">
             <a:extLst xmlns:a="http://schemas.openxmlformats.org/drawingml/2006/main">
               <a:ext uri="{FF2B5EF4-FFF2-40B4-BE49-F238E27FC236}">
-                <a16:creationId xmlns:a16="http://schemas.microsoft.com/office/drawing/2014/main" id="{973AFCED-52CF-4591-B808-A414CA3B3345}"/>
+                <a16:creationId xmlns:a16="http://schemas.microsoft.com/office/drawing/2014/main" id="{AC1B028E-9976-4B86-91C2-4F60FC866178}"/>
               </a:ext>
             </a:extLst>
           </p:cNvPr>
@@ -5776,7 +5776,7 @@
           <p:cNvPr id="19" name="">
             <a:extLst xmlns:a="http://schemas.openxmlformats.org/drawingml/2006/main">
               <a:ext uri="{FF2B5EF4-FFF2-40B4-BE49-F238E27FC236}">
-                <a16:creationId xmlns:a16="http://schemas.microsoft.com/office/drawing/2014/main" id="{5D1F8658-4843-4EF8-8F95-7D49889C19B4}"/>
+                <a16:creationId xmlns:a16="http://schemas.microsoft.com/office/drawing/2014/main" id="{128CA747-DCA2-472C-9B86-BA8EF55E4C5D}"/>
               </a:ext>
             </a:extLst>
           </p:cNvPr>
@@ -5811,7 +5811,7 @@
           <p:cNvPr id="20" name="">
             <a:extLst xmlns:a="http://schemas.openxmlformats.org/drawingml/2006/main">
               <a:ext uri="{FF2B5EF4-FFF2-40B4-BE49-F238E27FC236}">
-                <a16:creationId xmlns:a16="http://schemas.microsoft.com/office/drawing/2014/main" id="{3667BA8F-335D-4395-BD1E-CBEE94D0AEEB}"/>
+                <a16:creationId xmlns:a16="http://schemas.microsoft.com/office/drawing/2014/main" id="{C8AC304A-B2FF-4D94-9312-BBA88CCA9E43}"/>
               </a:ext>
             </a:extLst>
           </p:cNvPr>
@@ -5842,7 +5842,7 @@
           <p:cNvPr id="21" name="">
             <a:extLst xmlns:a="http://schemas.openxmlformats.org/drawingml/2006/main">
               <a:ext uri="{FF2B5EF4-FFF2-40B4-BE49-F238E27FC236}">
-                <a16:creationId xmlns:a16="http://schemas.microsoft.com/office/drawing/2014/main" id="{C8ACE92C-96C3-4FBF-A6DE-084282262FCC}"/>
+                <a16:creationId xmlns:a16="http://schemas.microsoft.com/office/drawing/2014/main" id="{AC16572D-8141-49ED-BBB7-F1FE563ED692}"/>
               </a:ext>
             </a:extLst>
           </p:cNvPr>
@@ -5892,7 +5892,7 @@
           <p:cNvPr id="22" name="">
             <a:extLst xmlns:a="http://schemas.openxmlformats.org/drawingml/2006/main">
               <a:ext uri="{FF2B5EF4-FFF2-40B4-BE49-F238E27FC236}">
-                <a16:creationId xmlns:a16="http://schemas.microsoft.com/office/drawing/2014/main" id="{5EC3EF48-D6FB-48F6-AE4C-02A954C615F9}"/>
+                <a16:creationId xmlns:a16="http://schemas.microsoft.com/office/drawing/2014/main" id="{D315EC30-5028-4D6F-8361-BCF984919AF8}"/>
               </a:ext>
             </a:extLst>
           </p:cNvPr>
@@ -5940,7 +5940,7 @@
     </p:spTree>
     <p:extLst>
       <p:ext uri="{BB962C8B-B14F-4D97-AF65-F5344CB8AC3E}">
-        <p14:creationId xmlns:p14="http://schemas.microsoft.com/office/powerpoint/2010/main" val="408775535"/>
+        <p14:creationId xmlns:p14="http://schemas.microsoft.com/office/powerpoint/2010/main" val="1764470854"/>
       </p:ext>
     </p:extLst>
   </p:cSld>
@@ -5971,7 +5971,7 @@
           <p:cNvPr id="23" name="">
             <a:extLst xmlns:a="http://schemas.openxmlformats.org/drawingml/2006/main">
               <a:ext uri="{FF2B5EF4-FFF2-40B4-BE49-F238E27FC236}">
-                <a16:creationId xmlns:a16="http://schemas.microsoft.com/office/drawing/2014/main" id="{4C5BD896-3B56-4487-87A4-88C93DFC4D37}"/>
+                <a16:creationId xmlns:a16="http://schemas.microsoft.com/office/drawing/2014/main" id="{6A29E635-C04C-4BDE-9F7E-48B9FBAAC474}"/>
               </a:ext>
             </a:extLst>
           </p:cNvPr>
@@ -6021,7 +6021,7 @@
           <p:cNvPr id="2" name="">
             <a:extLst xmlns:a="http://schemas.openxmlformats.org/drawingml/2006/main">
               <a:ext uri="{FF2B5EF4-FFF2-40B4-BE49-F238E27FC236}">
-                <a16:creationId xmlns:a16="http://schemas.microsoft.com/office/drawing/2014/main" id="{87E08D6D-B52E-4564-BC60-28D39A2A6A79}"/>
+                <a16:creationId xmlns:a16="http://schemas.microsoft.com/office/drawing/2014/main" id="{AC9E4346-3751-4B1A-AB94-CE96141756B8}"/>
               </a:ext>
             </a:extLst>
           </p:cNvPr>
@@ -6071,7 +6071,7 @@
           <p:cNvPr id="3" name="">
             <a:extLst xmlns:a="http://schemas.openxmlformats.org/drawingml/2006/main">
               <a:ext uri="{FF2B5EF4-FFF2-40B4-BE49-F238E27FC236}">
-                <a16:creationId xmlns:a16="http://schemas.microsoft.com/office/drawing/2014/main" id="{9A498C12-4D9F-46C1-BE0B-9CD86D07C53C}"/>
+                <a16:creationId xmlns:a16="http://schemas.microsoft.com/office/drawing/2014/main" id="{59C75BC0-4F11-45EF-8E97-DB17FB2FDA4C}"/>
               </a:ext>
             </a:extLst>
           </p:cNvPr>
@@ -6121,7 +6121,7 @@
           <p:cNvPr id="4" name="">
             <a:extLst xmlns:a="http://schemas.openxmlformats.org/drawingml/2006/main">
               <a:ext uri="{FF2B5EF4-FFF2-40B4-BE49-F238E27FC236}">
-                <a16:creationId xmlns:a16="http://schemas.microsoft.com/office/drawing/2014/main" id="{AE37E28D-40BC-43CE-9311-2FA2063D1D8F}"/>
+                <a16:creationId xmlns:a16="http://schemas.microsoft.com/office/drawing/2014/main" id="{6FC73FC9-2661-44BD-B98C-0E2F2D0ABC10}"/>
               </a:ext>
             </a:extLst>
           </p:cNvPr>
@@ -6171,7 +6171,7 @@
           <p:cNvPr id="5" name="">
             <a:extLst xmlns:a="http://schemas.openxmlformats.org/drawingml/2006/main">
               <a:ext uri="{FF2B5EF4-FFF2-40B4-BE49-F238E27FC236}">
-                <a16:creationId xmlns:a16="http://schemas.microsoft.com/office/drawing/2014/main" id="{76D7BFC6-120C-4BB9-AA0D-B61071607246}"/>
+                <a16:creationId xmlns:a16="http://schemas.microsoft.com/office/drawing/2014/main" id="{68119A06-5510-4CE4-AE40-A6A2EC0D5032}"/>
               </a:ext>
             </a:extLst>
           </p:cNvPr>
@@ -6204,7 +6204,7 @@
           <p:cNvPr id="6" name="">
             <a:extLst xmlns:a="http://schemas.openxmlformats.org/drawingml/2006/main">
               <a:ext uri="{FF2B5EF4-FFF2-40B4-BE49-F238E27FC236}">
-                <a16:creationId xmlns:a16="http://schemas.microsoft.com/office/drawing/2014/main" id="{D89489E8-F386-4471-A013-397A13607CE9}"/>
+                <a16:creationId xmlns:a16="http://schemas.microsoft.com/office/drawing/2014/main" id="{7BA80F93-2CB7-4EB6-9A57-87E5A98F8EE3}"/>
               </a:ext>
             </a:extLst>
           </p:cNvPr>
@@ -6254,7 +6254,7 @@
           <p:cNvPr id="7" name="">
             <a:extLst xmlns:a="http://schemas.openxmlformats.org/drawingml/2006/main">
               <a:ext uri="{FF2B5EF4-FFF2-40B4-BE49-F238E27FC236}">
-                <a16:creationId xmlns:a16="http://schemas.microsoft.com/office/drawing/2014/main" id="{E1D94150-CB04-42CD-ADA0-402889A673DE}"/>
+                <a16:creationId xmlns:a16="http://schemas.microsoft.com/office/drawing/2014/main" id="{71592C87-4CD6-4FE6-8FDB-55B8817E1A10}"/>
               </a:ext>
             </a:extLst>
           </p:cNvPr>
@@ -6289,7 +6289,7 @@
           <p:cNvPr id="8" name="">
             <a:extLst xmlns:a="http://schemas.openxmlformats.org/drawingml/2006/main">
               <a:ext uri="{FF2B5EF4-FFF2-40B4-BE49-F238E27FC236}">
-                <a16:creationId xmlns:a16="http://schemas.microsoft.com/office/drawing/2014/main" id="{588A8628-64FA-4AAC-9930-1EC12BE17DF7}"/>
+                <a16:creationId xmlns:a16="http://schemas.microsoft.com/office/drawing/2014/main" id="{2BFC190C-0FB7-4BFF-A53E-9C91E39B0133}"/>
               </a:ext>
             </a:extLst>
           </p:cNvPr>
@@ -6320,7 +6320,7 @@
           <p:cNvPr id="9" name="">
             <a:extLst xmlns:a="http://schemas.openxmlformats.org/drawingml/2006/main">
               <a:ext uri="{FF2B5EF4-FFF2-40B4-BE49-F238E27FC236}">
-                <a16:creationId xmlns:a16="http://schemas.microsoft.com/office/drawing/2014/main" id="{0E4EAFBE-78B1-4FC8-95A4-CE26C7966DDC}"/>
+                <a16:creationId xmlns:a16="http://schemas.microsoft.com/office/drawing/2014/main" id="{992A2637-23AB-43B0-BA81-D80F18E60E2E}"/>
               </a:ext>
             </a:extLst>
           </p:cNvPr>
@@ -6370,7 +6370,7 @@
           <p:cNvPr id="10" name="">
             <a:extLst xmlns:a="http://schemas.openxmlformats.org/drawingml/2006/main">
               <a:ext uri="{FF2B5EF4-FFF2-40B4-BE49-F238E27FC236}">
-                <a16:creationId xmlns:a16="http://schemas.microsoft.com/office/drawing/2014/main" id="{0E0C7473-6D47-42BA-AC40-C47E1FC5CA74}"/>
+                <a16:creationId xmlns:a16="http://schemas.microsoft.com/office/drawing/2014/main" id="{858C1FB8-B3AB-4F67-B020-DDF9A3853D5D}"/>
               </a:ext>
             </a:extLst>
           </p:cNvPr>
@@ -6420,7 +6420,7 @@
           <p:cNvPr id="11" name="">
             <a:extLst xmlns:a="http://schemas.openxmlformats.org/drawingml/2006/main">
               <a:ext uri="{FF2B5EF4-FFF2-40B4-BE49-F238E27FC236}">
-                <a16:creationId xmlns:a16="http://schemas.microsoft.com/office/drawing/2014/main" id="{62355C34-430F-4E01-977B-EBF2A4CA4E26}"/>
+                <a16:creationId xmlns:a16="http://schemas.microsoft.com/office/drawing/2014/main" id="{299BAE8F-37BB-474A-B555-56FAD6421484}"/>
               </a:ext>
             </a:extLst>
           </p:cNvPr>
@@ -6455,7 +6455,7 @@
           <p:cNvPr id="12" name="">
             <a:extLst xmlns:a="http://schemas.openxmlformats.org/drawingml/2006/main">
               <a:ext uri="{FF2B5EF4-FFF2-40B4-BE49-F238E27FC236}">
-                <a16:creationId xmlns:a16="http://schemas.microsoft.com/office/drawing/2014/main" id="{34112BF0-C58F-43E5-A692-FF51BA8FCE34}"/>
+                <a16:creationId xmlns:a16="http://schemas.microsoft.com/office/drawing/2014/main" id="{91F7C259-4D7D-4486-BD2E-B5BD0F80E981}"/>
               </a:ext>
             </a:extLst>
           </p:cNvPr>
@@ -6486,7 +6486,7 @@
           <p:cNvPr id="13" name="">
             <a:extLst xmlns:a="http://schemas.openxmlformats.org/drawingml/2006/main">
               <a:ext uri="{FF2B5EF4-FFF2-40B4-BE49-F238E27FC236}">
-                <a16:creationId xmlns:a16="http://schemas.microsoft.com/office/drawing/2014/main" id="{FC438A2A-A439-4DA8-A854-765DFA4E4DA9}"/>
+                <a16:creationId xmlns:a16="http://schemas.microsoft.com/office/drawing/2014/main" id="{AC4BA331-3F36-4D1A-B106-9E203F970DD8}"/>
               </a:ext>
             </a:extLst>
           </p:cNvPr>
@@ -6536,7 +6536,7 @@
           <p:cNvPr id="14" name="">
             <a:extLst xmlns:a="http://schemas.openxmlformats.org/drawingml/2006/main">
               <a:ext uri="{FF2B5EF4-FFF2-40B4-BE49-F238E27FC236}">
-                <a16:creationId xmlns:a16="http://schemas.microsoft.com/office/drawing/2014/main" id="{02472A19-1169-4CF9-B86B-CE2E9258403C}"/>
+                <a16:creationId xmlns:a16="http://schemas.microsoft.com/office/drawing/2014/main" id="{6C98FF53-0087-4A9F-9DC4-ACCDAF54B543}"/>
               </a:ext>
             </a:extLst>
           </p:cNvPr>
@@ -6586,7 +6586,7 @@
           <p:cNvPr id="15" name="">
             <a:extLst xmlns:a="http://schemas.openxmlformats.org/drawingml/2006/main">
               <a:ext uri="{FF2B5EF4-FFF2-40B4-BE49-F238E27FC236}">
-                <a16:creationId xmlns:a16="http://schemas.microsoft.com/office/drawing/2014/main" id="{72FC5B0A-8CA5-41C8-83C0-07F5201EE994}"/>
+                <a16:creationId xmlns:a16="http://schemas.microsoft.com/office/drawing/2014/main" id="{FF6C97FA-C09C-4840-BE9C-37BCF53FF581}"/>
               </a:ext>
             </a:extLst>
           </p:cNvPr>
@@ -6621,7 +6621,7 @@
           <p:cNvPr id="16" name="">
             <a:extLst xmlns:a="http://schemas.openxmlformats.org/drawingml/2006/main">
               <a:ext uri="{FF2B5EF4-FFF2-40B4-BE49-F238E27FC236}">
-                <a16:creationId xmlns:a16="http://schemas.microsoft.com/office/drawing/2014/main" id="{F65B19E4-4F20-4DBF-9C99-D06DEEB39C51}"/>
+                <a16:creationId xmlns:a16="http://schemas.microsoft.com/office/drawing/2014/main" id="{E3C280A3-22E3-470C-8E26-4E26A4FD7818}"/>
               </a:ext>
             </a:extLst>
           </p:cNvPr>
@@ -6652,7 +6652,7 @@
           <p:cNvPr id="17" name="">
             <a:extLst xmlns:a="http://schemas.openxmlformats.org/drawingml/2006/main">
               <a:ext uri="{FF2B5EF4-FFF2-40B4-BE49-F238E27FC236}">
-                <a16:creationId xmlns:a16="http://schemas.microsoft.com/office/drawing/2014/main" id="{DA1081F8-4075-45BB-9BD3-CBE1D1D16E27}"/>
+                <a16:creationId xmlns:a16="http://schemas.microsoft.com/office/drawing/2014/main" id="{2F882BAE-E4DB-47BD-B09C-147A154B3819}"/>
               </a:ext>
             </a:extLst>
           </p:cNvPr>
@@ -6702,7 +6702,7 @@
           <p:cNvPr id="18" name="">
             <a:extLst xmlns:a="http://schemas.openxmlformats.org/drawingml/2006/main">
               <a:ext uri="{FF2B5EF4-FFF2-40B4-BE49-F238E27FC236}">
-                <a16:creationId xmlns:a16="http://schemas.microsoft.com/office/drawing/2014/main" id="{F2EC04A8-F049-4969-B524-317BA2B12715}"/>
+                <a16:creationId xmlns:a16="http://schemas.microsoft.com/office/drawing/2014/main" id="{78E8292A-754E-44BA-800B-A614C791376E}"/>
               </a:ext>
             </a:extLst>
           </p:cNvPr>
@@ -6752,7 +6752,7 @@
           <p:cNvPr id="19" name="">
             <a:extLst xmlns:a="http://schemas.openxmlformats.org/drawingml/2006/main">
               <a:ext uri="{FF2B5EF4-FFF2-40B4-BE49-F238E27FC236}">
-                <a16:creationId xmlns:a16="http://schemas.microsoft.com/office/drawing/2014/main" id="{EF95F008-69EF-4F5D-8E12-C82C91D36B06}"/>
+                <a16:creationId xmlns:a16="http://schemas.microsoft.com/office/drawing/2014/main" id="{013F429C-92C0-4C66-956A-D5148A3190F2}"/>
               </a:ext>
             </a:extLst>
           </p:cNvPr>
@@ -6787,7 +6787,7 @@
           <p:cNvPr id="20" name="">
             <a:extLst xmlns:a="http://schemas.openxmlformats.org/drawingml/2006/main">
               <a:ext uri="{FF2B5EF4-FFF2-40B4-BE49-F238E27FC236}">
-                <a16:creationId xmlns:a16="http://schemas.microsoft.com/office/drawing/2014/main" id="{C09CE281-502C-4666-8338-C8BE68B4F232}"/>
+                <a16:creationId xmlns:a16="http://schemas.microsoft.com/office/drawing/2014/main" id="{2F8168B4-B5C7-448F-8535-CDFA6D6BE621}"/>
               </a:ext>
             </a:extLst>
           </p:cNvPr>
@@ -6818,7 +6818,7 @@
           <p:cNvPr id="21" name="">
             <a:extLst xmlns:a="http://schemas.openxmlformats.org/drawingml/2006/main">
               <a:ext uri="{FF2B5EF4-FFF2-40B4-BE49-F238E27FC236}">
-                <a16:creationId xmlns:a16="http://schemas.microsoft.com/office/drawing/2014/main" id="{B8D91618-9AB5-4C7F-8EFB-2A20534CAAE6}"/>
+                <a16:creationId xmlns:a16="http://schemas.microsoft.com/office/drawing/2014/main" id="{662F6AC1-7AE9-46EA-8E1E-262A734DE314}"/>
               </a:ext>
             </a:extLst>
           </p:cNvPr>
@@ -6868,7 +6868,7 @@
           <p:cNvPr id="22" name="">
             <a:extLst xmlns:a="http://schemas.openxmlformats.org/drawingml/2006/main">
               <a:ext uri="{FF2B5EF4-FFF2-40B4-BE49-F238E27FC236}">
-                <a16:creationId xmlns:a16="http://schemas.microsoft.com/office/drawing/2014/main" id="{D725C061-1C26-4003-9A2B-26BF56A442CA}"/>
+                <a16:creationId xmlns:a16="http://schemas.microsoft.com/office/drawing/2014/main" id="{504AA8DC-DB3D-4D24-B6EC-A0CE86A192A3}"/>
               </a:ext>
             </a:extLst>
           </p:cNvPr>
@@ -6916,7 +6916,7 @@
     </p:spTree>
     <p:extLst>
       <p:ext uri="{BB962C8B-B14F-4D97-AF65-F5344CB8AC3E}">
-        <p14:creationId xmlns:p14="http://schemas.microsoft.com/office/powerpoint/2010/main" val="472032917"/>
+        <p14:creationId xmlns:p14="http://schemas.microsoft.com/office/powerpoint/2010/main" val="4411616"/>
       </p:ext>
     </p:extLst>
   </p:cSld>
@@ -6947,7 +6947,7 @@
           <p:cNvPr id="23" name="">
             <a:extLst xmlns:a="http://schemas.openxmlformats.org/drawingml/2006/main">
               <a:ext uri="{FF2B5EF4-FFF2-40B4-BE49-F238E27FC236}">
-                <a16:creationId xmlns:a16="http://schemas.microsoft.com/office/drawing/2014/main" id="{66096384-9F57-40B4-B10E-B420D5CA6CA7}"/>
+                <a16:creationId xmlns:a16="http://schemas.microsoft.com/office/drawing/2014/main" id="{0DF58990-435F-482B-B90F-490679429803}"/>
               </a:ext>
             </a:extLst>
           </p:cNvPr>
@@ -6997,7 +6997,7 @@
           <p:cNvPr id="2" name="">
             <a:extLst xmlns:a="http://schemas.openxmlformats.org/drawingml/2006/main">
               <a:ext uri="{FF2B5EF4-FFF2-40B4-BE49-F238E27FC236}">
-                <a16:creationId xmlns:a16="http://schemas.microsoft.com/office/drawing/2014/main" id="{51B10F68-818A-4F2F-A61D-520C8FCB1803}"/>
+                <a16:creationId xmlns:a16="http://schemas.microsoft.com/office/drawing/2014/main" id="{154BF404-3546-46DC-99B7-048355A23EAC}"/>
               </a:ext>
             </a:extLst>
           </p:cNvPr>
@@ -7047,7 +7047,7 @@
           <p:cNvPr id="3" name="">
             <a:extLst xmlns:a="http://schemas.openxmlformats.org/drawingml/2006/main">
               <a:ext uri="{FF2B5EF4-FFF2-40B4-BE49-F238E27FC236}">
-                <a16:creationId xmlns:a16="http://schemas.microsoft.com/office/drawing/2014/main" id="{40E75954-983C-480F-9A36-E9C98C35489C}"/>
+                <a16:creationId xmlns:a16="http://schemas.microsoft.com/office/drawing/2014/main" id="{0BF19342-380B-474E-AEC4-F69A7CF7816F}"/>
               </a:ext>
             </a:extLst>
           </p:cNvPr>
@@ -7097,7 +7097,7 @@
           <p:cNvPr id="4" name="">
             <a:extLst xmlns:a="http://schemas.openxmlformats.org/drawingml/2006/main">
               <a:ext uri="{FF2B5EF4-FFF2-40B4-BE49-F238E27FC236}">
-                <a16:creationId xmlns:a16="http://schemas.microsoft.com/office/drawing/2014/main" id="{549F34AF-60B1-4C92-8686-26F73F01CA80}"/>
+                <a16:creationId xmlns:a16="http://schemas.microsoft.com/office/drawing/2014/main" id="{F8CFD340-9435-4532-AC8C-CBFBC61CDF24}"/>
               </a:ext>
             </a:extLst>
           </p:cNvPr>
@@ -7147,7 +7147,7 @@
           <p:cNvPr id="5" name="">
             <a:extLst xmlns:a="http://schemas.openxmlformats.org/drawingml/2006/main">
               <a:ext uri="{FF2B5EF4-FFF2-40B4-BE49-F238E27FC236}">
-                <a16:creationId xmlns:a16="http://schemas.microsoft.com/office/drawing/2014/main" id="{E2602B65-0C9A-4632-A4AD-A2C5078AA360}"/>
+                <a16:creationId xmlns:a16="http://schemas.microsoft.com/office/drawing/2014/main" id="{C25E82D7-647B-491C-8293-6573EB686330}"/>
               </a:ext>
             </a:extLst>
           </p:cNvPr>
@@ -7180,7 +7180,7 @@
           <p:cNvPr id="6" name="">
             <a:extLst xmlns:a="http://schemas.openxmlformats.org/drawingml/2006/main">
               <a:ext uri="{FF2B5EF4-FFF2-40B4-BE49-F238E27FC236}">
-                <a16:creationId xmlns:a16="http://schemas.microsoft.com/office/drawing/2014/main" id="{1A71DEE4-B565-41F3-9C8E-9B1BA68DC3F0}"/>
+                <a16:creationId xmlns:a16="http://schemas.microsoft.com/office/drawing/2014/main" id="{9EA351BD-FDB4-4221-B839-BC093CFA40BE}"/>
               </a:ext>
             </a:extLst>
           </p:cNvPr>
@@ -7230,7 +7230,7 @@
           <p:cNvPr id="7" name="">
             <a:extLst xmlns:a="http://schemas.openxmlformats.org/drawingml/2006/main">
               <a:ext uri="{FF2B5EF4-FFF2-40B4-BE49-F238E27FC236}">
-                <a16:creationId xmlns:a16="http://schemas.microsoft.com/office/drawing/2014/main" id="{06034620-E362-4F4D-9D18-7077F20D2202}"/>
+                <a16:creationId xmlns:a16="http://schemas.microsoft.com/office/drawing/2014/main" id="{5E17B30E-DFCB-49A2-A0C9-67BE6F0529F2}"/>
               </a:ext>
             </a:extLst>
           </p:cNvPr>
@@ -7265,7 +7265,7 @@
           <p:cNvPr id="8" name="">
             <a:extLst xmlns:a="http://schemas.openxmlformats.org/drawingml/2006/main">
               <a:ext uri="{FF2B5EF4-FFF2-40B4-BE49-F238E27FC236}">
-                <a16:creationId xmlns:a16="http://schemas.microsoft.com/office/drawing/2014/main" id="{D05965CA-5357-4A7B-8110-E6BB00C53630}"/>
+                <a16:creationId xmlns:a16="http://schemas.microsoft.com/office/drawing/2014/main" id="{9BAB29F7-A5CE-42E7-855E-CB9131117C16}"/>
               </a:ext>
             </a:extLst>
           </p:cNvPr>
@@ -7296,7 +7296,7 @@
           <p:cNvPr id="9" name="">
             <a:extLst xmlns:a="http://schemas.openxmlformats.org/drawingml/2006/main">
               <a:ext uri="{FF2B5EF4-FFF2-40B4-BE49-F238E27FC236}">
-                <a16:creationId xmlns:a16="http://schemas.microsoft.com/office/drawing/2014/main" id="{F417BCFE-D0A4-4D3E-87F4-F844019E4B37}"/>
+                <a16:creationId xmlns:a16="http://schemas.microsoft.com/office/drawing/2014/main" id="{62EDF25D-CE35-4BAC-B22C-C6D41BBAFC59}"/>
               </a:ext>
             </a:extLst>
           </p:cNvPr>
@@ -7346,7 +7346,7 @@
           <p:cNvPr id="10" name="">
             <a:extLst xmlns:a="http://schemas.openxmlformats.org/drawingml/2006/main">
               <a:ext uri="{FF2B5EF4-FFF2-40B4-BE49-F238E27FC236}">
-                <a16:creationId xmlns:a16="http://schemas.microsoft.com/office/drawing/2014/main" id="{321BDD9B-C688-4097-8E95-65EA2982DECD}"/>
+                <a16:creationId xmlns:a16="http://schemas.microsoft.com/office/drawing/2014/main" id="{E8E44202-FAFE-4B6A-AF94-4902BD25AC27}"/>
               </a:ext>
             </a:extLst>
           </p:cNvPr>
@@ -7396,7 +7396,7 @@
           <p:cNvPr id="11" name="">
             <a:extLst xmlns:a="http://schemas.openxmlformats.org/drawingml/2006/main">
               <a:ext uri="{FF2B5EF4-FFF2-40B4-BE49-F238E27FC236}">
-                <a16:creationId xmlns:a16="http://schemas.microsoft.com/office/drawing/2014/main" id="{9BA3EAC1-E711-46E4-8D39-6C6B94B68F47}"/>
+                <a16:creationId xmlns:a16="http://schemas.microsoft.com/office/drawing/2014/main" id="{B0A1CB29-8FFC-4659-9248-C5842C24804E}"/>
               </a:ext>
             </a:extLst>
           </p:cNvPr>
@@ -7431,7 +7431,7 @@
           <p:cNvPr id="12" name="">
             <a:extLst xmlns:a="http://schemas.openxmlformats.org/drawingml/2006/main">
               <a:ext uri="{FF2B5EF4-FFF2-40B4-BE49-F238E27FC236}">
-                <a16:creationId xmlns:a16="http://schemas.microsoft.com/office/drawing/2014/main" id="{4692B30E-59B0-44C4-B957-40737AD4D26C}"/>
+                <a16:creationId xmlns:a16="http://schemas.microsoft.com/office/drawing/2014/main" id="{13328D8D-C31B-4618-80E5-DBAED70B0C92}"/>
               </a:ext>
             </a:extLst>
           </p:cNvPr>
@@ -7462,7 +7462,7 @@
           <p:cNvPr id="13" name="">
             <a:extLst xmlns:a="http://schemas.openxmlformats.org/drawingml/2006/main">
               <a:ext uri="{FF2B5EF4-FFF2-40B4-BE49-F238E27FC236}">
-                <a16:creationId xmlns:a16="http://schemas.microsoft.com/office/drawing/2014/main" id="{CDA996EE-C9A5-449C-8D2E-F2EA7EE6DBDF}"/>
+                <a16:creationId xmlns:a16="http://schemas.microsoft.com/office/drawing/2014/main" id="{225FCCA6-3AF5-4CB8-B97E-F612F33CCAAB}"/>
               </a:ext>
             </a:extLst>
           </p:cNvPr>
@@ -7512,7 +7512,7 @@
           <p:cNvPr id="14" name="">
             <a:extLst xmlns:a="http://schemas.openxmlformats.org/drawingml/2006/main">
               <a:ext uri="{FF2B5EF4-FFF2-40B4-BE49-F238E27FC236}">
-                <a16:creationId xmlns:a16="http://schemas.microsoft.com/office/drawing/2014/main" id="{5DB76647-8C94-4F35-AC51-D86F9B3C6472}"/>
+                <a16:creationId xmlns:a16="http://schemas.microsoft.com/office/drawing/2014/main" id="{C4332D5D-7EDF-4F8F-82BD-DF020B000D4B}"/>
               </a:ext>
             </a:extLst>
           </p:cNvPr>
@@ -7562,7 +7562,7 @@
           <p:cNvPr id="15" name="">
             <a:extLst xmlns:a="http://schemas.openxmlformats.org/drawingml/2006/main">
               <a:ext uri="{FF2B5EF4-FFF2-40B4-BE49-F238E27FC236}">
-                <a16:creationId xmlns:a16="http://schemas.microsoft.com/office/drawing/2014/main" id="{297BEFC9-6ACA-479E-B79A-DEE3ABD39EC5}"/>
+                <a16:creationId xmlns:a16="http://schemas.microsoft.com/office/drawing/2014/main" id="{775E78AE-9CDB-445B-B1BF-21683C6B6DE2}"/>
               </a:ext>
             </a:extLst>
           </p:cNvPr>
@@ -7597,7 +7597,7 @@
           <p:cNvPr id="16" name="">
             <a:extLst xmlns:a="http://schemas.openxmlformats.org/drawingml/2006/main">
               <a:ext uri="{FF2B5EF4-FFF2-40B4-BE49-F238E27FC236}">
-                <a16:creationId xmlns:a16="http://schemas.microsoft.com/office/drawing/2014/main" id="{D1C6C551-E27D-4E05-8C61-4A9DDBC03E66}"/>
+                <a16:creationId xmlns:a16="http://schemas.microsoft.com/office/drawing/2014/main" id="{E6836379-487A-4746-9FDD-D9AA99F3BAC1}"/>
               </a:ext>
             </a:extLst>
           </p:cNvPr>
@@ -7628,7 +7628,7 @@
           <p:cNvPr id="17" name="">
             <a:extLst xmlns:a="http://schemas.openxmlformats.org/drawingml/2006/main">
               <a:ext uri="{FF2B5EF4-FFF2-40B4-BE49-F238E27FC236}">
-                <a16:creationId xmlns:a16="http://schemas.microsoft.com/office/drawing/2014/main" id="{C0AEE3F5-11D0-40E6-8107-61B2CF3C7E6A}"/>
+                <a16:creationId xmlns:a16="http://schemas.microsoft.com/office/drawing/2014/main" id="{6C665C85-CDA2-4451-A3D1-5B1F93097349}"/>
               </a:ext>
             </a:extLst>
           </p:cNvPr>
@@ -7678,7 +7678,7 @@
           <p:cNvPr id="18" name="">
             <a:extLst xmlns:a="http://schemas.openxmlformats.org/drawingml/2006/main">
               <a:ext uri="{FF2B5EF4-FFF2-40B4-BE49-F238E27FC236}">
-                <a16:creationId xmlns:a16="http://schemas.microsoft.com/office/drawing/2014/main" id="{50FEAC81-EE94-462D-8CA4-B1E299BF07C2}"/>
+                <a16:creationId xmlns:a16="http://schemas.microsoft.com/office/drawing/2014/main" id="{8D5DDCED-A135-4201-AF39-A5E676967188}"/>
               </a:ext>
             </a:extLst>
           </p:cNvPr>
@@ -7728,7 +7728,7 @@
           <p:cNvPr id="19" name="">
             <a:extLst xmlns:a="http://schemas.openxmlformats.org/drawingml/2006/main">
               <a:ext uri="{FF2B5EF4-FFF2-40B4-BE49-F238E27FC236}">
-                <a16:creationId xmlns:a16="http://schemas.microsoft.com/office/drawing/2014/main" id="{44DB6BDE-F95D-48D0-8523-9C507937DDEB}"/>
+                <a16:creationId xmlns:a16="http://schemas.microsoft.com/office/drawing/2014/main" id="{C5491095-7942-4C83-9254-C857113987F4}"/>
               </a:ext>
             </a:extLst>
           </p:cNvPr>
@@ -7763,7 +7763,7 @@
           <p:cNvPr id="20" name="">
             <a:extLst xmlns:a="http://schemas.openxmlformats.org/drawingml/2006/main">
               <a:ext uri="{FF2B5EF4-FFF2-40B4-BE49-F238E27FC236}">
-                <a16:creationId xmlns:a16="http://schemas.microsoft.com/office/drawing/2014/main" id="{974A7B21-13FD-4376-B306-E29D25B8EE00}"/>
+                <a16:creationId xmlns:a16="http://schemas.microsoft.com/office/drawing/2014/main" id="{9AE8D455-4817-4EB6-9152-4848F5D3034A}"/>
               </a:ext>
             </a:extLst>
           </p:cNvPr>
@@ -7794,7 +7794,7 @@
           <p:cNvPr id="21" name="">
             <a:extLst xmlns:a="http://schemas.openxmlformats.org/drawingml/2006/main">
               <a:ext uri="{FF2B5EF4-FFF2-40B4-BE49-F238E27FC236}">
-                <a16:creationId xmlns:a16="http://schemas.microsoft.com/office/drawing/2014/main" id="{D2648D23-78CF-45C1-8D53-1FBE27E354A6}"/>
+                <a16:creationId xmlns:a16="http://schemas.microsoft.com/office/drawing/2014/main" id="{F2B2D5CD-42D7-48B6-BFD2-EE1272FF7596}"/>
               </a:ext>
             </a:extLst>
           </p:cNvPr>
@@ -7844,7 +7844,7 @@
           <p:cNvPr id="22" name="">
             <a:extLst xmlns:a="http://schemas.openxmlformats.org/drawingml/2006/main">
               <a:ext uri="{FF2B5EF4-FFF2-40B4-BE49-F238E27FC236}">
-                <a16:creationId xmlns:a16="http://schemas.microsoft.com/office/drawing/2014/main" id="{6549C353-A6DE-4063-98B1-E14B91EEAE22}"/>
+                <a16:creationId xmlns:a16="http://schemas.microsoft.com/office/drawing/2014/main" id="{1752121A-3ED8-46E0-86DA-250DFCEEBEC1}"/>
               </a:ext>
             </a:extLst>
           </p:cNvPr>
@@ -7892,7 +7892,7 @@
     </p:spTree>
     <p:extLst>
       <p:ext uri="{BB962C8B-B14F-4D97-AF65-F5344CB8AC3E}">
-        <p14:creationId xmlns:p14="http://schemas.microsoft.com/office/powerpoint/2010/main" val="1087825800"/>
+        <p14:creationId xmlns:p14="http://schemas.microsoft.com/office/powerpoint/2010/main" val="1474145148"/>
       </p:ext>
     </p:extLst>
   </p:cSld>
@@ -7923,7 +7923,7 @@
           <p:cNvPr id="16" name="">
             <a:extLst xmlns:a="http://schemas.openxmlformats.org/drawingml/2006/main">
               <a:ext uri="{FF2B5EF4-FFF2-40B4-BE49-F238E27FC236}">
-                <a16:creationId xmlns:a16="http://schemas.microsoft.com/office/drawing/2014/main" id="{5A208054-2ED5-466C-A503-5DE9A484C486}"/>
+                <a16:creationId xmlns:a16="http://schemas.microsoft.com/office/drawing/2014/main" id="{1E06A39F-7CA9-40AD-BE35-A65CF4317417}"/>
               </a:ext>
             </a:extLst>
           </p:cNvPr>
@@ -7973,7 +7973,7 @@
           <p:cNvPr id="2" name="">
             <a:extLst xmlns:a="http://schemas.openxmlformats.org/drawingml/2006/main">
               <a:ext uri="{FF2B5EF4-FFF2-40B4-BE49-F238E27FC236}">
-                <a16:creationId xmlns:a16="http://schemas.microsoft.com/office/drawing/2014/main" id="{C092C851-5F11-4250-8079-2DA0BA75A7AA}"/>
+                <a16:creationId xmlns:a16="http://schemas.microsoft.com/office/drawing/2014/main" id="{E652F400-480C-4CD6-A6E7-0279B61ECAC1}"/>
               </a:ext>
             </a:extLst>
           </p:cNvPr>
@@ -8023,7 +8023,7 @@
           <p:cNvPr id="3" name="">
             <a:extLst xmlns:a="http://schemas.openxmlformats.org/drawingml/2006/main">
               <a:ext uri="{FF2B5EF4-FFF2-40B4-BE49-F238E27FC236}">
-                <a16:creationId xmlns:a16="http://schemas.microsoft.com/office/drawing/2014/main" id="{FCA83B3D-93BE-43FD-A8F3-8EFD793CD7D3}"/>
+                <a16:creationId xmlns:a16="http://schemas.microsoft.com/office/drawing/2014/main" id="{568DDBF5-F462-4299-BC8B-EB809A472461}"/>
               </a:ext>
             </a:extLst>
           </p:cNvPr>
@@ -8073,7 +8073,7 @@
           <p:cNvPr id="4" name="">
             <a:extLst xmlns:a="http://schemas.openxmlformats.org/drawingml/2006/main">
               <a:ext uri="{FF2B5EF4-FFF2-40B4-BE49-F238E27FC236}">
-                <a16:creationId xmlns:a16="http://schemas.microsoft.com/office/drawing/2014/main" id="{F0341159-6F30-47B1-BC33-ECCDA4EA197C}"/>
+                <a16:creationId xmlns:a16="http://schemas.microsoft.com/office/drawing/2014/main" id="{1DD2A84E-C95A-443D-AEE8-EB2E79F9501C}"/>
               </a:ext>
             </a:extLst>
           </p:cNvPr>
@@ -8123,7 +8123,7 @@
           <p:cNvPr id="5" name="">
             <a:extLst xmlns:a="http://schemas.openxmlformats.org/drawingml/2006/main">
               <a:ext uri="{FF2B5EF4-FFF2-40B4-BE49-F238E27FC236}">
-                <a16:creationId xmlns:a16="http://schemas.microsoft.com/office/drawing/2014/main" id="{C3D33AA7-EFFF-4679-945E-F664AFF3AB95}"/>
+                <a16:creationId xmlns:a16="http://schemas.microsoft.com/office/drawing/2014/main" id="{A810D966-43DD-403D-BFBA-3C4108C43936}"/>
               </a:ext>
             </a:extLst>
           </p:cNvPr>
@@ -8173,7 +8173,7 @@
           <p:cNvPr id="6" name="">
             <a:extLst xmlns:a="http://schemas.openxmlformats.org/drawingml/2006/main">
               <a:ext uri="{FF2B5EF4-FFF2-40B4-BE49-F238E27FC236}">
-                <a16:creationId xmlns:a16="http://schemas.microsoft.com/office/drawing/2014/main" id="{E54613BF-A548-4B63-B037-D17C2FBEAC9A}"/>
+                <a16:creationId xmlns:a16="http://schemas.microsoft.com/office/drawing/2014/main" id="{CE6DAF5B-9A6D-4493-837A-4EFE1E3CFD27}"/>
               </a:ext>
             </a:extLst>
           </p:cNvPr>
@@ -8240,7 +8240,7 @@
           <p:cNvPr id="7" name="">
             <a:extLst xmlns:a="http://schemas.openxmlformats.org/drawingml/2006/main">
               <a:ext uri="{FF2B5EF4-FFF2-40B4-BE49-F238E27FC236}">
-                <a16:creationId xmlns:a16="http://schemas.microsoft.com/office/drawing/2014/main" id="{A409923C-D79A-49A1-A8C8-D226291A87E5}"/>
+                <a16:creationId xmlns:a16="http://schemas.microsoft.com/office/drawing/2014/main" id="{81F7BB89-695E-4612-96AF-080F2009ACB2}"/>
               </a:ext>
             </a:extLst>
           </p:cNvPr>
@@ -8290,7 +8290,7 @@
           <p:cNvPr id="8" name="">
             <a:extLst xmlns:a="http://schemas.openxmlformats.org/drawingml/2006/main">
               <a:ext uri="{FF2B5EF4-FFF2-40B4-BE49-F238E27FC236}">
-                <a16:creationId xmlns:a16="http://schemas.microsoft.com/office/drawing/2014/main" id="{7FFFD0F6-04E2-472E-8B72-53B15DAD96EB}"/>
+                <a16:creationId xmlns:a16="http://schemas.microsoft.com/office/drawing/2014/main" id="{878F79BB-2ED7-420D-AD43-346001B3F388}"/>
               </a:ext>
             </a:extLst>
           </p:cNvPr>
@@ -8357,7 +8357,7 @@
           <p:cNvPr id="9" name="">
             <a:extLst xmlns:a="http://schemas.openxmlformats.org/drawingml/2006/main">
               <a:ext uri="{FF2B5EF4-FFF2-40B4-BE49-F238E27FC236}">
-                <a16:creationId xmlns:a16="http://schemas.microsoft.com/office/drawing/2014/main" id="{E39A728F-4F6F-4A24-BB0F-D80D9510EDBE}"/>
+                <a16:creationId xmlns:a16="http://schemas.microsoft.com/office/drawing/2014/main" id="{3B6E6CDD-74F9-4B98-B208-8BAD3FB760E5}"/>
               </a:ext>
             </a:extLst>
           </p:cNvPr>
@@ -8407,7 +8407,7 @@
           <p:cNvPr id="10" name="">
             <a:extLst xmlns:a="http://schemas.openxmlformats.org/drawingml/2006/main">
               <a:ext uri="{FF2B5EF4-FFF2-40B4-BE49-F238E27FC236}">
-                <a16:creationId xmlns:a16="http://schemas.microsoft.com/office/drawing/2014/main" id="{3F029DF1-5BA1-463A-8431-2331BBD60CC2}"/>
+                <a16:creationId xmlns:a16="http://schemas.microsoft.com/office/drawing/2014/main" id="{C79F6713-9FBD-432F-99C9-8A1D33B18E07}"/>
               </a:ext>
             </a:extLst>
           </p:cNvPr>
@@ -8474,7 +8474,7 @@
           <p:cNvPr id="11" name="">
             <a:extLst xmlns:a="http://schemas.openxmlformats.org/drawingml/2006/main">
               <a:ext uri="{FF2B5EF4-FFF2-40B4-BE49-F238E27FC236}">
-                <a16:creationId xmlns:a16="http://schemas.microsoft.com/office/drawing/2014/main" id="{C316D2B1-415B-4858-AA38-0650B86F09B8}"/>
+                <a16:creationId xmlns:a16="http://schemas.microsoft.com/office/drawing/2014/main" id="{5141E1B8-ED21-4451-8A24-9FCD0414A8CB}"/>
               </a:ext>
             </a:extLst>
           </p:cNvPr>
@@ -8509,7 +8509,7 @@
           <p:cNvPr id="12" name="">
             <a:extLst xmlns:a="http://schemas.openxmlformats.org/drawingml/2006/main">
               <a:ext uri="{FF2B5EF4-FFF2-40B4-BE49-F238E27FC236}">
-                <a16:creationId xmlns:a16="http://schemas.microsoft.com/office/drawing/2014/main" id="{AD2F7230-8AB5-43C9-8DC3-58FAD7A5D9F2}"/>
+                <a16:creationId xmlns:a16="http://schemas.microsoft.com/office/drawing/2014/main" id="{8B54AF8B-2FBC-4B02-8484-0A322B3BF299}"/>
               </a:ext>
             </a:extLst>
           </p:cNvPr>
@@ -8559,7 +8559,7 @@
           <p:cNvPr id="13" name="">
             <a:extLst xmlns:a="http://schemas.openxmlformats.org/drawingml/2006/main">
               <a:ext uri="{FF2B5EF4-FFF2-40B4-BE49-F238E27FC236}">
-                <a16:creationId xmlns:a16="http://schemas.microsoft.com/office/drawing/2014/main" id="{72BFC9CD-7A72-4FF6-9A78-E79D78D310B8}"/>
+                <a16:creationId xmlns:a16="http://schemas.microsoft.com/office/drawing/2014/main" id="{D87F12DD-5D63-4B8A-B5E5-36B6E397AF03}"/>
               </a:ext>
             </a:extLst>
           </p:cNvPr>
@@ -8609,7 +8609,7 @@
           <p:cNvPr id="14" name="">
             <a:extLst xmlns:a="http://schemas.openxmlformats.org/drawingml/2006/main">
               <a:ext uri="{FF2B5EF4-FFF2-40B4-BE49-F238E27FC236}">
-                <a16:creationId xmlns:a16="http://schemas.microsoft.com/office/drawing/2014/main" id="{B793DD50-F0F4-4DBB-A768-C883E832BA2E}"/>
+                <a16:creationId xmlns:a16="http://schemas.microsoft.com/office/drawing/2014/main" id="{67C75B9F-19A6-48A1-929A-D259B51BDA2F}"/>
               </a:ext>
             </a:extLst>
           </p:cNvPr>
@@ -8640,7 +8640,7 @@
           <p:cNvPr id="15" name="">
             <a:extLst xmlns:a="http://schemas.openxmlformats.org/drawingml/2006/main">
               <a:ext uri="{FF2B5EF4-FFF2-40B4-BE49-F238E27FC236}">
-                <a16:creationId xmlns:a16="http://schemas.microsoft.com/office/drawing/2014/main" id="{BC220687-B0BE-4F13-BB19-D9E914EE1F81}"/>
+                <a16:creationId xmlns:a16="http://schemas.microsoft.com/office/drawing/2014/main" id="{396EC8A5-6CB4-4834-9A6A-5EC6B01820A0}"/>
               </a:ext>
             </a:extLst>
           </p:cNvPr>
@@ -8688,7 +8688,7 @@
     </p:spTree>
     <p:extLst>
       <p:ext uri="{BB962C8B-B14F-4D97-AF65-F5344CB8AC3E}">
-        <p14:creationId xmlns:p14="http://schemas.microsoft.com/office/powerpoint/2010/main" val="1629218359"/>
+        <p14:creationId xmlns:p14="http://schemas.microsoft.com/office/powerpoint/2010/main" val="1452170283"/>
       </p:ext>
     </p:extLst>
   </p:cSld>
@@ -8719,7 +8719,7 @@
           <p:cNvPr id="19" name="">
             <a:extLst xmlns:a="http://schemas.openxmlformats.org/drawingml/2006/main">
               <a:ext uri="{FF2B5EF4-FFF2-40B4-BE49-F238E27FC236}">
-                <a16:creationId xmlns:a16="http://schemas.microsoft.com/office/drawing/2014/main" id="{186450D4-BC86-496E-8973-8CC509C488AE}"/>
+                <a16:creationId xmlns:a16="http://schemas.microsoft.com/office/drawing/2014/main" id="{18E53630-3172-4D7D-AE9F-547B7EBBD3E8}"/>
               </a:ext>
             </a:extLst>
           </p:cNvPr>
@@ -8769,7 +8769,7 @@
           <p:cNvPr id="2" name="">
             <a:extLst xmlns:a="http://schemas.openxmlformats.org/drawingml/2006/main">
               <a:ext uri="{FF2B5EF4-FFF2-40B4-BE49-F238E27FC236}">
-                <a16:creationId xmlns:a16="http://schemas.microsoft.com/office/drawing/2014/main" id="{DBDE725C-0C2A-43F6-A660-6AFFD1C8AE87}"/>
+                <a16:creationId xmlns:a16="http://schemas.microsoft.com/office/drawing/2014/main" id="{CC40083F-E938-4DDD-8395-D0E412308304}"/>
               </a:ext>
             </a:extLst>
           </p:cNvPr>
@@ -8819,7 +8819,7 @@
           <p:cNvPr id="3" name="">
             <a:extLst xmlns:a="http://schemas.openxmlformats.org/drawingml/2006/main">
               <a:ext uri="{FF2B5EF4-FFF2-40B4-BE49-F238E27FC236}">
-                <a16:creationId xmlns:a16="http://schemas.microsoft.com/office/drawing/2014/main" id="{E75287BD-D7BB-4765-A902-D3DCD9D5E73D}"/>
+                <a16:creationId xmlns:a16="http://schemas.microsoft.com/office/drawing/2014/main" id="{1D1A9922-BF2C-4F5E-A899-C89C9102EF47}"/>
               </a:ext>
             </a:extLst>
           </p:cNvPr>
@@ -8869,7 +8869,7 @@
           <p:cNvPr id="4" name="">
             <a:extLst xmlns:a="http://schemas.openxmlformats.org/drawingml/2006/main">
               <a:ext uri="{FF2B5EF4-FFF2-40B4-BE49-F238E27FC236}">
-                <a16:creationId xmlns:a16="http://schemas.microsoft.com/office/drawing/2014/main" id="{AAB77AC6-D796-471F-ACF9-16A88C87E92D}"/>
+                <a16:creationId xmlns:a16="http://schemas.microsoft.com/office/drawing/2014/main" id="{26CADE02-2DBC-4E5B-A22D-13F7998304DE}"/>
               </a:ext>
             </a:extLst>
           </p:cNvPr>
@@ -8919,7 +8919,7 @@
           <p:cNvPr id="5" name="">
             <a:extLst xmlns:a="http://schemas.openxmlformats.org/drawingml/2006/main">
               <a:ext uri="{FF2B5EF4-FFF2-40B4-BE49-F238E27FC236}">
-                <a16:creationId xmlns:a16="http://schemas.microsoft.com/office/drawing/2014/main" id="{E7F981B9-A309-48DE-98EF-0E0DA6259A34}"/>
+                <a16:creationId xmlns:a16="http://schemas.microsoft.com/office/drawing/2014/main" id="{D65ECE06-3037-4540-AB8B-522BAD313C4B}"/>
               </a:ext>
             </a:extLst>
           </p:cNvPr>
@@ -8954,7 +8954,7 @@
           <p:cNvPr id="6" name="">
             <a:extLst xmlns:a="http://schemas.openxmlformats.org/drawingml/2006/main">
               <a:ext uri="{FF2B5EF4-FFF2-40B4-BE49-F238E27FC236}">
-                <a16:creationId xmlns:a16="http://schemas.microsoft.com/office/drawing/2014/main" id="{93A0A190-86D2-4C57-B39C-A12507CA10F5}"/>
+                <a16:creationId xmlns:a16="http://schemas.microsoft.com/office/drawing/2014/main" id="{8B6A0AC2-4C5A-4181-A38E-C04FCC8E10F9}"/>
               </a:ext>
             </a:extLst>
           </p:cNvPr>
@@ -9004,7 +9004,7 @@
           <p:cNvPr id="7" name="">
             <a:extLst xmlns:a="http://schemas.openxmlformats.org/drawingml/2006/main">
               <a:ext uri="{FF2B5EF4-FFF2-40B4-BE49-F238E27FC236}">
-                <a16:creationId xmlns:a16="http://schemas.microsoft.com/office/drawing/2014/main" id="{DBA20428-1BCE-41F9-9CF7-40BC20102AC0}"/>
+                <a16:creationId xmlns:a16="http://schemas.microsoft.com/office/drawing/2014/main" id="{F3B1B7EE-C228-4E4D-BE8F-AFE8CF39ADA6}"/>
               </a:ext>
             </a:extLst>
           </p:cNvPr>
@@ -9054,7 +9054,7 @@
           <p:cNvPr id="8" name="">
             <a:extLst xmlns:a="http://schemas.openxmlformats.org/drawingml/2006/main">
               <a:ext uri="{FF2B5EF4-FFF2-40B4-BE49-F238E27FC236}">
-                <a16:creationId xmlns:a16="http://schemas.microsoft.com/office/drawing/2014/main" id="{A992210D-F764-46AA-863F-34C7670C3BDC}"/>
+                <a16:creationId xmlns:a16="http://schemas.microsoft.com/office/drawing/2014/main" id="{CFAEF34A-BB94-447C-A93A-7ED8EC68115E}"/>
               </a:ext>
             </a:extLst>
           </p:cNvPr>
@@ -9104,7 +9104,7 @@
           <p:cNvPr id="9" name="">
             <a:extLst xmlns:a="http://schemas.openxmlformats.org/drawingml/2006/main">
               <a:ext uri="{FF2B5EF4-FFF2-40B4-BE49-F238E27FC236}">
-                <a16:creationId xmlns:a16="http://schemas.microsoft.com/office/drawing/2014/main" id="{AC97FB36-00F9-4F11-8BD3-E4029412117D}"/>
+                <a16:creationId xmlns:a16="http://schemas.microsoft.com/office/drawing/2014/main" id="{41F29137-5F61-443A-B8FA-140C958E5396}"/>
               </a:ext>
             </a:extLst>
           </p:cNvPr>
@@ -9154,7 +9154,7 @@
           <p:cNvPr id="10" name="">
             <a:extLst xmlns:a="http://schemas.openxmlformats.org/drawingml/2006/main">
               <a:ext uri="{FF2B5EF4-FFF2-40B4-BE49-F238E27FC236}">
-                <a16:creationId xmlns:a16="http://schemas.microsoft.com/office/drawing/2014/main" id="{4402483E-E7F1-4F4F-8EFE-7C024BF1DD98}"/>
+                <a16:creationId xmlns:a16="http://schemas.microsoft.com/office/drawing/2014/main" id="{5209EA97-1155-4619-883A-28034577CBFC}"/>
               </a:ext>
             </a:extLst>
           </p:cNvPr>
@@ -9189,7 +9189,7 @@
           <p:cNvPr id="11" name="">
             <a:extLst xmlns:a="http://schemas.openxmlformats.org/drawingml/2006/main">
               <a:ext uri="{FF2B5EF4-FFF2-40B4-BE49-F238E27FC236}">
-                <a16:creationId xmlns:a16="http://schemas.microsoft.com/office/drawing/2014/main" id="{E4A4C77C-DADB-466C-8073-E4558B586C82}"/>
+                <a16:creationId xmlns:a16="http://schemas.microsoft.com/office/drawing/2014/main" id="{3B6C8A8C-A2B7-42E4-AC34-7838E24AA15B}"/>
               </a:ext>
             </a:extLst>
           </p:cNvPr>
@@ -9239,7 +9239,7 @@
           <p:cNvPr id="12" name="">
             <a:extLst xmlns:a="http://schemas.openxmlformats.org/drawingml/2006/main">
               <a:ext uri="{FF2B5EF4-FFF2-40B4-BE49-F238E27FC236}">
-                <a16:creationId xmlns:a16="http://schemas.microsoft.com/office/drawing/2014/main" id="{FE4BE2A2-3447-488F-8C65-3B2AB881CCFC}"/>
+                <a16:creationId xmlns:a16="http://schemas.microsoft.com/office/drawing/2014/main" id="{888BE45C-7B6C-45C6-AA69-C6EB903F89AC}"/>
               </a:ext>
             </a:extLst>
           </p:cNvPr>
@@ -9289,7 +9289,7 @@
           <p:cNvPr id="13" name="">
             <a:extLst xmlns:a="http://schemas.openxmlformats.org/drawingml/2006/main">
               <a:ext uri="{FF2B5EF4-FFF2-40B4-BE49-F238E27FC236}">
-                <a16:creationId xmlns:a16="http://schemas.microsoft.com/office/drawing/2014/main" id="{862134A4-377B-4850-931C-B2C16227F19E}"/>
+                <a16:creationId xmlns:a16="http://schemas.microsoft.com/office/drawing/2014/main" id="{D83C6951-FD24-4F9F-BDD3-8A78C4C2EF50}"/>
               </a:ext>
             </a:extLst>
           </p:cNvPr>
@@ -9339,7 +9339,7 @@
           <p:cNvPr id="14" name="">
             <a:extLst xmlns:a="http://schemas.openxmlformats.org/drawingml/2006/main">
               <a:ext uri="{FF2B5EF4-FFF2-40B4-BE49-F238E27FC236}">
-                <a16:creationId xmlns:a16="http://schemas.microsoft.com/office/drawing/2014/main" id="{245194C8-5BF3-44EA-9C68-1EB2E7AA8545}"/>
+                <a16:creationId xmlns:a16="http://schemas.microsoft.com/office/drawing/2014/main" id="{8E9498AD-E196-49F4-B582-7DEE9A6F5BED}"/>
               </a:ext>
             </a:extLst>
           </p:cNvPr>
@@ -9389,7 +9389,7 @@
           <p:cNvPr id="15" name="">
             <a:extLst xmlns:a="http://schemas.openxmlformats.org/drawingml/2006/main">
               <a:ext uri="{FF2B5EF4-FFF2-40B4-BE49-F238E27FC236}">
-                <a16:creationId xmlns:a16="http://schemas.microsoft.com/office/drawing/2014/main" id="{B57E23F3-7BF6-4322-9EB0-AEBA2D17AC2D}"/>
+                <a16:creationId xmlns:a16="http://schemas.microsoft.com/office/drawing/2014/main" id="{E10800E3-08A8-45A7-830B-C8CC6F9CD79D}"/>
               </a:ext>
             </a:extLst>
           </p:cNvPr>
@@ -9424,7 +9424,7 @@
           <p:cNvPr id="16" name="">
             <a:extLst xmlns:a="http://schemas.openxmlformats.org/drawingml/2006/main">
               <a:ext uri="{FF2B5EF4-FFF2-40B4-BE49-F238E27FC236}">
-                <a16:creationId xmlns:a16="http://schemas.microsoft.com/office/drawing/2014/main" id="{BD17C05F-4456-43A2-AD41-4960C3763D4D}"/>
+                <a16:creationId xmlns:a16="http://schemas.microsoft.com/office/drawing/2014/main" id="{0168DA86-A2C0-4F81-8D44-892527B760F8}"/>
               </a:ext>
             </a:extLst>
           </p:cNvPr>
@@ -9474,7 +9474,7 @@
           <p:cNvPr id="17" name="">
             <a:extLst xmlns:a="http://schemas.openxmlformats.org/drawingml/2006/main">
               <a:ext uri="{FF2B5EF4-FFF2-40B4-BE49-F238E27FC236}">
-                <a16:creationId xmlns:a16="http://schemas.microsoft.com/office/drawing/2014/main" id="{4037941B-9949-431D-A5A7-8055C4C97E44}"/>
+                <a16:creationId xmlns:a16="http://schemas.microsoft.com/office/drawing/2014/main" id="{0E2D61A7-3D2B-406D-879D-87864151C5F1}"/>
               </a:ext>
             </a:extLst>
           </p:cNvPr>
@@ -9524,7 +9524,7 @@
           <p:cNvPr id="18" name="">
             <a:extLst xmlns:a="http://schemas.openxmlformats.org/drawingml/2006/main">
               <a:ext uri="{FF2B5EF4-FFF2-40B4-BE49-F238E27FC236}">
-                <a16:creationId xmlns:a16="http://schemas.microsoft.com/office/drawing/2014/main" id="{4787276F-B4D6-4CBE-B8C6-ECA25ED77FB3}"/>
+                <a16:creationId xmlns:a16="http://schemas.microsoft.com/office/drawing/2014/main" id="{B6E18385-6317-42E5-A65A-AAEEA2155DA0}"/>
               </a:ext>
             </a:extLst>
           </p:cNvPr>
@@ -9572,7 +9572,7 @@
     </p:spTree>
     <p:extLst>
       <p:ext uri="{BB962C8B-B14F-4D97-AF65-F5344CB8AC3E}">
-        <p14:creationId xmlns:p14="http://schemas.microsoft.com/office/powerpoint/2010/main" val="744980083"/>
+        <p14:creationId xmlns:p14="http://schemas.microsoft.com/office/powerpoint/2010/main" val="1804921695"/>
       </p:ext>
     </p:extLst>
   </p:cSld>
@@ -9603,7 +9603,7 @@
           <p:cNvPr id="16" name="">
             <a:extLst xmlns:a="http://schemas.openxmlformats.org/drawingml/2006/main">
               <a:ext uri="{FF2B5EF4-FFF2-40B4-BE49-F238E27FC236}">
-                <a16:creationId xmlns:a16="http://schemas.microsoft.com/office/drawing/2014/main" id="{F49BF8A2-8B27-445D-B76F-18EB024E24D7}"/>
+                <a16:creationId xmlns:a16="http://schemas.microsoft.com/office/drawing/2014/main" id="{35B65D5F-1245-4A9F-B05E-1B63A1E8C46C}"/>
               </a:ext>
             </a:extLst>
           </p:cNvPr>
@@ -9653,7 +9653,7 @@
           <p:cNvPr id="2" name="">
             <a:extLst xmlns:a="http://schemas.openxmlformats.org/drawingml/2006/main">
               <a:ext uri="{FF2B5EF4-FFF2-40B4-BE49-F238E27FC236}">
-                <a16:creationId xmlns:a16="http://schemas.microsoft.com/office/drawing/2014/main" id="{09899979-A980-42CD-A628-2442FA5EA6A1}"/>
+                <a16:creationId xmlns:a16="http://schemas.microsoft.com/office/drawing/2014/main" id="{EF944497-9886-4D61-B54D-437A3C929AF0}"/>
               </a:ext>
             </a:extLst>
           </p:cNvPr>
@@ -9703,7 +9703,7 @@
           <p:cNvPr id="3" name="">
             <a:extLst xmlns:a="http://schemas.openxmlformats.org/drawingml/2006/main">
               <a:ext uri="{FF2B5EF4-FFF2-40B4-BE49-F238E27FC236}">
-                <a16:creationId xmlns:a16="http://schemas.microsoft.com/office/drawing/2014/main" id="{6B597B1D-5DEC-4E41-8A04-739CAF468585}"/>
+                <a16:creationId xmlns:a16="http://schemas.microsoft.com/office/drawing/2014/main" id="{49FFEEF5-4219-4892-BB45-D49149BA4B5A}"/>
               </a:ext>
             </a:extLst>
           </p:cNvPr>
@@ -9753,7 +9753,7 @@
           <p:cNvPr id="4" name="">
             <a:extLst xmlns:a="http://schemas.openxmlformats.org/drawingml/2006/main">
               <a:ext uri="{FF2B5EF4-FFF2-40B4-BE49-F238E27FC236}">
-                <a16:creationId xmlns:a16="http://schemas.microsoft.com/office/drawing/2014/main" id="{2B927F8E-4BFB-4D60-8DCA-382876572CE7}"/>
+                <a16:creationId xmlns:a16="http://schemas.microsoft.com/office/drawing/2014/main" id="{1438740D-5EC7-4C04-A2CB-8496B11CE9AC}"/>
               </a:ext>
             </a:extLst>
           </p:cNvPr>
@@ -9803,7 +9803,7 @@
           <p:cNvPr id="5" name="">
             <a:extLst xmlns:a="http://schemas.openxmlformats.org/drawingml/2006/main">
               <a:ext uri="{FF2B5EF4-FFF2-40B4-BE49-F238E27FC236}">
-                <a16:creationId xmlns:a16="http://schemas.microsoft.com/office/drawing/2014/main" id="{C64B21A8-8494-4322-8E35-DFD557678BE7}"/>
+                <a16:creationId xmlns:a16="http://schemas.microsoft.com/office/drawing/2014/main" id="{243C92A6-5FA5-4559-A520-D14E5AFA85C3}"/>
               </a:ext>
             </a:extLst>
           </p:cNvPr>
@@ -9836,7 +9836,7 @@
           <p:cNvPr id="6" name="">
             <a:extLst xmlns:a="http://schemas.openxmlformats.org/drawingml/2006/main">
               <a:ext uri="{FF2B5EF4-FFF2-40B4-BE49-F238E27FC236}">
-                <a16:creationId xmlns:a16="http://schemas.microsoft.com/office/drawing/2014/main" id="{360DE1FC-BA91-44F0-A6DE-35B2B0A3465B}"/>
+                <a16:creationId xmlns:a16="http://schemas.microsoft.com/office/drawing/2014/main" id="{8F75F34D-4AFA-4358-8CD2-98C80436C389}"/>
               </a:ext>
             </a:extLst>
           </p:cNvPr>
@@ -9886,7 +9886,7 @@
           <p:cNvPr id="7" name="">
             <a:extLst xmlns:a="http://schemas.openxmlformats.org/drawingml/2006/main">
               <a:ext uri="{FF2B5EF4-FFF2-40B4-BE49-F238E27FC236}">
-                <a16:creationId xmlns:a16="http://schemas.microsoft.com/office/drawing/2014/main" id="{4D7F8927-D921-4A8D-B271-CEC838F0DC3C}"/>
+                <a16:creationId xmlns:a16="http://schemas.microsoft.com/office/drawing/2014/main" id="{2B7DDEE1-CD62-4BA3-A5F4-65CAEFB0363D}"/>
               </a:ext>
             </a:extLst>
           </p:cNvPr>
@@ -9936,7 +9936,7 @@
           <p:cNvPr id="8" name="">
             <a:extLst xmlns:a="http://schemas.openxmlformats.org/drawingml/2006/main">
               <a:ext uri="{FF2B5EF4-FFF2-40B4-BE49-F238E27FC236}">
-                <a16:creationId xmlns:a16="http://schemas.microsoft.com/office/drawing/2014/main" id="{6ABD40DB-881C-411B-AF39-F057E0ED93EE}"/>
+                <a16:creationId xmlns:a16="http://schemas.microsoft.com/office/drawing/2014/main" id="{8255E73E-A518-4B1F-B7FA-A1B931F4D100}"/>
               </a:ext>
             </a:extLst>
           </p:cNvPr>
@@ -9986,7 +9986,7 @@
           <p:cNvPr id="9" name="">
             <a:extLst xmlns:a="http://schemas.openxmlformats.org/drawingml/2006/main">
               <a:ext uri="{FF2B5EF4-FFF2-40B4-BE49-F238E27FC236}">
-                <a16:creationId xmlns:a16="http://schemas.microsoft.com/office/drawing/2014/main" id="{544FCC48-B0F9-43BD-8A51-E09C52671DCA}"/>
+                <a16:creationId xmlns:a16="http://schemas.microsoft.com/office/drawing/2014/main" id="{7B3350E4-12DE-4AF8-BC37-C0473EB67FD8}"/>
               </a:ext>
             </a:extLst>
           </p:cNvPr>
@@ -10036,7 +10036,7 @@
           <p:cNvPr id="10" name="">
             <a:extLst xmlns:a="http://schemas.openxmlformats.org/drawingml/2006/main">
               <a:ext uri="{FF2B5EF4-FFF2-40B4-BE49-F238E27FC236}">
-                <a16:creationId xmlns:a16="http://schemas.microsoft.com/office/drawing/2014/main" id="{97960C40-185F-45E4-B9EC-01806A6E8FB1}"/>
+                <a16:creationId xmlns:a16="http://schemas.microsoft.com/office/drawing/2014/main" id="{6596CF8D-8D19-41AE-8B71-820B1447B43A}"/>
               </a:ext>
             </a:extLst>
           </p:cNvPr>
@@ -10086,7 +10086,7 @@
           <p:cNvPr id="11" name="">
             <a:extLst xmlns:a="http://schemas.openxmlformats.org/drawingml/2006/main">
               <a:ext uri="{FF2B5EF4-FFF2-40B4-BE49-F238E27FC236}">
-                <a16:creationId xmlns:a16="http://schemas.microsoft.com/office/drawing/2014/main" id="{41F09399-402F-4F43-B179-C7FC56C2F215}"/>
+                <a16:creationId xmlns:a16="http://schemas.microsoft.com/office/drawing/2014/main" id="{DF5F6B2D-D875-432D-A90A-0FB5B92E8CFB}"/>
               </a:ext>
             </a:extLst>
           </p:cNvPr>
@@ -10117,7 +10117,7 @@
           <p:cNvPr id="12" name="">
             <a:extLst xmlns:a="http://schemas.openxmlformats.org/drawingml/2006/main">
               <a:ext uri="{FF2B5EF4-FFF2-40B4-BE49-F238E27FC236}">
-                <a16:creationId xmlns:a16="http://schemas.microsoft.com/office/drawing/2014/main" id="{6BAFF29F-3996-467E-B02C-2037001DCBC6}"/>
+                <a16:creationId xmlns:a16="http://schemas.microsoft.com/office/drawing/2014/main" id="{F1C56A59-11BB-497A-ACA6-2C65A2664C55}"/>
               </a:ext>
             </a:extLst>
           </p:cNvPr>
@@ -10167,7 +10167,7 @@
           <p:cNvPr id="13" name="">
             <a:extLst xmlns:a="http://schemas.openxmlformats.org/drawingml/2006/main">
               <a:ext uri="{FF2B5EF4-FFF2-40B4-BE49-F238E27FC236}">
-                <a16:creationId xmlns:a16="http://schemas.microsoft.com/office/drawing/2014/main" id="{C6BF2CFC-FF60-4042-9D0A-3D8ACFF41D5A}"/>
+                <a16:creationId xmlns:a16="http://schemas.microsoft.com/office/drawing/2014/main" id="{BD6842B0-75DA-40E1-8937-EA1134D8D624}"/>
               </a:ext>
             </a:extLst>
           </p:cNvPr>
@@ -10217,7 +10217,7 @@
           <p:cNvPr id="14" name="">
             <a:extLst xmlns:a="http://schemas.openxmlformats.org/drawingml/2006/main">
               <a:ext uri="{FF2B5EF4-FFF2-40B4-BE49-F238E27FC236}">
-                <a16:creationId xmlns:a16="http://schemas.microsoft.com/office/drawing/2014/main" id="{2C3A7872-DBC9-4F81-BA4F-C5C52BFDEF88}"/>
+                <a16:creationId xmlns:a16="http://schemas.microsoft.com/office/drawing/2014/main" id="{7BA8E267-72E0-46C6-8AD9-0EFF54D9F56D}"/>
               </a:ext>
             </a:extLst>
           </p:cNvPr>
@@ -10256,7 +10256,7 @@
           <p:nvPr/>
         </p:nvPicPr>
         <p:blipFill>
-          <a:blip xmlns:r="http://schemas.openxmlformats.org/officeDocument/2006/relationships" xmlns:a="http://schemas.openxmlformats.org/drawingml/2006/main" r:embed="Rbb4111933e8944bd"/>
+          <a:blip xmlns:r="http://schemas.openxmlformats.org/officeDocument/2006/relationships" xmlns:a="http://schemas.openxmlformats.org/drawingml/2006/main" r:embed="R9b06b88fe81a4e09"/>
           <a:stretch xmlns:a="http://schemas.openxmlformats.org/drawingml/2006/main"/>
         </p:blipFill>
         <p:spPr>
@@ -10274,7 +10274,7 @@
     </p:spTree>
     <p:extLst>
       <p:ext uri="{BB962C8B-B14F-4D97-AF65-F5344CB8AC3E}">
-        <p14:creationId xmlns:p14="http://schemas.microsoft.com/office/powerpoint/2010/main" val="384877494"/>
+        <p14:creationId xmlns:p14="http://schemas.microsoft.com/office/powerpoint/2010/main" val="1140922353"/>
       </p:ext>
     </p:extLst>
   </p:cSld>
@@ -10305,7 +10305,7 @@
           <p:cNvPr id="18" name="">
             <a:extLst xmlns:a="http://schemas.openxmlformats.org/drawingml/2006/main">
               <a:ext uri="{FF2B5EF4-FFF2-40B4-BE49-F238E27FC236}">
-                <a16:creationId xmlns:a16="http://schemas.microsoft.com/office/drawing/2014/main" id="{FACE1DC2-D758-44E5-825A-C1710D640228}"/>
+                <a16:creationId xmlns:a16="http://schemas.microsoft.com/office/drawing/2014/main" id="{7EA8E3EB-14A1-4452-B959-43A9FF5468E3}"/>
               </a:ext>
             </a:extLst>
           </p:cNvPr>
@@ -10355,7 +10355,7 @@
           <p:cNvPr id="2" name="">
             <a:extLst xmlns:a="http://schemas.openxmlformats.org/drawingml/2006/main">
               <a:ext uri="{FF2B5EF4-FFF2-40B4-BE49-F238E27FC236}">
-                <a16:creationId xmlns:a16="http://schemas.microsoft.com/office/drawing/2014/main" id="{444A7BB9-9154-4FB2-BCA3-1686F3302C8C}"/>
+                <a16:creationId xmlns:a16="http://schemas.microsoft.com/office/drawing/2014/main" id="{AB2AD2E7-8DC0-48B3-968B-FF804D6CD759}"/>
               </a:ext>
             </a:extLst>
           </p:cNvPr>
@@ -10405,7 +10405,7 @@
           <p:cNvPr id="3" name="">
             <a:extLst xmlns:a="http://schemas.openxmlformats.org/drawingml/2006/main">
               <a:ext uri="{FF2B5EF4-FFF2-40B4-BE49-F238E27FC236}">
-                <a16:creationId xmlns:a16="http://schemas.microsoft.com/office/drawing/2014/main" id="{7390993D-3A25-4EFC-8376-35C96CDBF114}"/>
+                <a16:creationId xmlns:a16="http://schemas.microsoft.com/office/drawing/2014/main" id="{7CAD26FF-9655-4099-8D6F-9FF14F975AED}"/>
               </a:ext>
             </a:extLst>
           </p:cNvPr>
@@ -10455,7 +10455,7 @@
           <p:cNvPr id="4" name="">
             <a:extLst xmlns:a="http://schemas.openxmlformats.org/drawingml/2006/main">
               <a:ext uri="{FF2B5EF4-FFF2-40B4-BE49-F238E27FC236}">
-                <a16:creationId xmlns:a16="http://schemas.microsoft.com/office/drawing/2014/main" id="{551290B8-2BDD-48F1-8766-7BEA234189A1}"/>
+                <a16:creationId xmlns:a16="http://schemas.microsoft.com/office/drawing/2014/main" id="{B95FE997-2E16-496C-897D-9DD1667F7DAC}"/>
               </a:ext>
             </a:extLst>
           </p:cNvPr>
@@ -10505,7 +10505,7 @@
           <p:cNvPr id="5" name="">
             <a:extLst xmlns:a="http://schemas.openxmlformats.org/drawingml/2006/main">
               <a:ext uri="{FF2B5EF4-FFF2-40B4-BE49-F238E27FC236}">
-                <a16:creationId xmlns:a16="http://schemas.microsoft.com/office/drawing/2014/main" id="{386326E3-BB07-401C-85AE-9B7945169998}"/>
+                <a16:creationId xmlns:a16="http://schemas.microsoft.com/office/drawing/2014/main" id="{065BE33D-AAD8-48CE-B86F-A0302AC6276C}"/>
               </a:ext>
             </a:extLst>
           </p:cNvPr>
@@ -10544,7 +10544,7 @@
           <p:nvPr/>
         </p:nvPicPr>
         <p:blipFill>
-          <a:blip xmlns:r="http://schemas.openxmlformats.org/officeDocument/2006/relationships" xmlns:a="http://schemas.openxmlformats.org/drawingml/2006/main" r:embed="Rc00e950668c746b2"/>
+          <a:blip xmlns:r="http://schemas.openxmlformats.org/officeDocument/2006/relationships" xmlns:a="http://schemas.openxmlformats.org/drawingml/2006/main" r:embed="R77d330e63449472c"/>
           <a:stretch xmlns:a="http://schemas.openxmlformats.org/drawingml/2006/main"/>
         </p:blipFill>
         <p:spPr>
@@ -10564,7 +10564,7 @@
           <p:cNvPr id="7" name="">
             <a:extLst xmlns:a="http://schemas.openxmlformats.org/drawingml/2006/main">
               <a:ext uri="{FF2B5EF4-FFF2-40B4-BE49-F238E27FC236}">
-                <a16:creationId xmlns:a16="http://schemas.microsoft.com/office/drawing/2014/main" id="{D29B324A-37B3-408E-AB01-13C926378A98}"/>
+                <a16:creationId xmlns:a16="http://schemas.microsoft.com/office/drawing/2014/main" id="{314C5092-3B3F-435E-B779-4766A15F52A8}"/>
               </a:ext>
             </a:extLst>
           </p:cNvPr>
@@ -10597,7 +10597,7 @@
           <p:cNvPr id="8" name="">
             <a:extLst xmlns:a="http://schemas.openxmlformats.org/drawingml/2006/main">
               <a:ext uri="{FF2B5EF4-FFF2-40B4-BE49-F238E27FC236}">
-                <a16:creationId xmlns:a16="http://schemas.microsoft.com/office/drawing/2014/main" id="{D9CBF477-BB32-4D8A-88E4-32DA3C60E5D6}"/>
+                <a16:creationId xmlns:a16="http://schemas.microsoft.com/office/drawing/2014/main" id="{8569D065-72B2-48A1-863F-F3A5E9F8DA86}"/>
               </a:ext>
             </a:extLst>
           </p:cNvPr>
@@ -10647,7 +10647,7 @@
           <p:cNvPr id="9" name="">
             <a:extLst xmlns:a="http://schemas.openxmlformats.org/drawingml/2006/main">
               <a:ext uri="{FF2B5EF4-FFF2-40B4-BE49-F238E27FC236}">
-                <a16:creationId xmlns:a16="http://schemas.microsoft.com/office/drawing/2014/main" id="{B701D703-160D-48F5-9378-88183E193732}"/>
+                <a16:creationId xmlns:a16="http://schemas.microsoft.com/office/drawing/2014/main" id="{47D826BB-97A4-4311-9B83-8585B7BC2B72}"/>
               </a:ext>
             </a:extLst>
           </p:cNvPr>
@@ -10697,7 +10697,7 @@
           <p:cNvPr id="10" name="">
             <a:extLst xmlns:a="http://schemas.openxmlformats.org/drawingml/2006/main">
               <a:ext uri="{FF2B5EF4-FFF2-40B4-BE49-F238E27FC236}">
-                <a16:creationId xmlns:a16="http://schemas.microsoft.com/office/drawing/2014/main" id="{90C4F2BB-3F7B-4AFF-A844-B092327F60F4}"/>
+                <a16:creationId xmlns:a16="http://schemas.microsoft.com/office/drawing/2014/main" id="{98B9EE9B-DB98-4CD2-A65A-3E00EB418AE7}"/>
               </a:ext>
             </a:extLst>
           </p:cNvPr>
@@ -10747,7 +10747,7 @@
           <p:cNvPr id="11" name="">
             <a:extLst xmlns:a="http://schemas.openxmlformats.org/drawingml/2006/main">
               <a:ext uri="{FF2B5EF4-FFF2-40B4-BE49-F238E27FC236}">
-                <a16:creationId xmlns:a16="http://schemas.microsoft.com/office/drawing/2014/main" id="{F805E416-D5DB-4D3C-8660-D634F57A0658}"/>
+                <a16:creationId xmlns:a16="http://schemas.microsoft.com/office/drawing/2014/main" id="{F1E1D784-7D6C-49CF-83CA-9121F5653EE8}"/>
               </a:ext>
             </a:extLst>
           </p:cNvPr>
@@ -10797,7 +10797,7 @@
           <p:cNvPr id="12" name="">
             <a:extLst xmlns:a="http://schemas.openxmlformats.org/drawingml/2006/main">
               <a:ext uri="{FF2B5EF4-FFF2-40B4-BE49-F238E27FC236}">
-                <a16:creationId xmlns:a16="http://schemas.microsoft.com/office/drawing/2014/main" id="{C61B5E2E-C81A-4C13-B10C-D28BA2A8D4E1}"/>
+                <a16:creationId xmlns:a16="http://schemas.microsoft.com/office/drawing/2014/main" id="{53B01AAA-8AEF-4A2A-9155-2FC57573EB3B}"/>
               </a:ext>
             </a:extLst>
           </p:cNvPr>
@@ -10847,7 +10847,7 @@
           <p:cNvPr id="13" name="">
             <a:extLst xmlns:a="http://schemas.openxmlformats.org/drawingml/2006/main">
               <a:ext uri="{FF2B5EF4-FFF2-40B4-BE49-F238E27FC236}">
-                <a16:creationId xmlns:a16="http://schemas.microsoft.com/office/drawing/2014/main" id="{B5FFA5CB-982B-44FF-8B71-B03C9221597C}"/>
+                <a16:creationId xmlns:a16="http://schemas.microsoft.com/office/drawing/2014/main" id="{E247C469-AB3E-48A1-8260-CFAFE07B3115}"/>
               </a:ext>
             </a:extLst>
           </p:cNvPr>
@@ -10897,7 +10897,7 @@
           <p:cNvPr id="14" name="">
             <a:extLst xmlns:a="http://schemas.openxmlformats.org/drawingml/2006/main">
               <a:ext uri="{FF2B5EF4-FFF2-40B4-BE49-F238E27FC236}">
-                <a16:creationId xmlns:a16="http://schemas.microsoft.com/office/drawing/2014/main" id="{77FEC215-B464-4686-9AA5-04A476B80C11}"/>
+                <a16:creationId xmlns:a16="http://schemas.microsoft.com/office/drawing/2014/main" id="{ED7F3D35-A34F-4859-A205-181D39937BD1}"/>
               </a:ext>
             </a:extLst>
           </p:cNvPr>
@@ -10947,7 +10947,7 @@
           <p:cNvPr id="15" name="">
             <a:extLst xmlns:a="http://schemas.openxmlformats.org/drawingml/2006/main">
               <a:ext uri="{FF2B5EF4-FFF2-40B4-BE49-F238E27FC236}">
-                <a16:creationId xmlns:a16="http://schemas.microsoft.com/office/drawing/2014/main" id="{57D0959D-6706-4518-9335-14A01698E93F}"/>
+                <a16:creationId xmlns:a16="http://schemas.microsoft.com/office/drawing/2014/main" id="{98390FC1-2833-48B5-8D2E-98574C88E103}"/>
               </a:ext>
             </a:extLst>
           </p:cNvPr>
@@ -10997,7 +10997,7 @@
           <p:cNvPr id="16" name="">
             <a:extLst xmlns:a="http://schemas.openxmlformats.org/drawingml/2006/main">
               <a:ext uri="{FF2B5EF4-FFF2-40B4-BE49-F238E27FC236}">
-                <a16:creationId xmlns:a16="http://schemas.microsoft.com/office/drawing/2014/main" id="{12B9E5D2-71A1-45B3-8255-9C75141BC872}"/>
+                <a16:creationId xmlns:a16="http://schemas.microsoft.com/office/drawing/2014/main" id="{4801651F-0F11-4E07-8C15-140A9334D2D5}"/>
               </a:ext>
             </a:extLst>
           </p:cNvPr>
@@ -11047,7 +11047,7 @@
           <p:cNvPr id="17" name="">
             <a:extLst xmlns:a="http://schemas.openxmlformats.org/drawingml/2006/main">
               <a:ext uri="{FF2B5EF4-FFF2-40B4-BE49-F238E27FC236}">
-                <a16:creationId xmlns:a16="http://schemas.microsoft.com/office/drawing/2014/main" id="{C371D596-6545-481E-8B0E-86BD5AC3F62C}"/>
+                <a16:creationId xmlns:a16="http://schemas.microsoft.com/office/drawing/2014/main" id="{980BC911-6F25-4E81-96A2-223FC2F2B84D}"/>
               </a:ext>
             </a:extLst>
           </p:cNvPr>
@@ -11095,7 +11095,7 @@
     </p:spTree>
     <p:extLst>
       <p:ext uri="{BB962C8B-B14F-4D97-AF65-F5344CB8AC3E}">
-        <p14:creationId xmlns:p14="http://schemas.microsoft.com/office/powerpoint/2010/main" val="233996910"/>
+        <p14:creationId xmlns:p14="http://schemas.microsoft.com/office/powerpoint/2010/main" val="1734258832"/>
       </p:ext>
     </p:extLst>
   </p:cSld>
@@ -11126,7 +11126,7 @@
           <p:cNvPr id="13" name="">
             <a:extLst xmlns:a="http://schemas.openxmlformats.org/drawingml/2006/main">
               <a:ext uri="{FF2B5EF4-FFF2-40B4-BE49-F238E27FC236}">
-                <a16:creationId xmlns:a16="http://schemas.microsoft.com/office/drawing/2014/main" id="{348C1055-C3C8-4862-9E29-47E8D97F8A4B}"/>
+                <a16:creationId xmlns:a16="http://schemas.microsoft.com/office/drawing/2014/main" id="{0BF70207-8456-4625-919F-39842071D2DA}"/>
               </a:ext>
             </a:extLst>
           </p:cNvPr>
@@ -11176,7 +11176,7 @@
           <p:cNvPr id="2" name="">
             <a:extLst xmlns:a="http://schemas.openxmlformats.org/drawingml/2006/main">
               <a:ext uri="{FF2B5EF4-FFF2-40B4-BE49-F238E27FC236}">
-                <a16:creationId xmlns:a16="http://schemas.microsoft.com/office/drawing/2014/main" id="{6B7C266B-DA9C-43E4-92EE-A439B1C114C8}"/>
+                <a16:creationId xmlns:a16="http://schemas.microsoft.com/office/drawing/2014/main" id="{AFE79887-AE81-46C7-89FD-954B1CED4610}"/>
               </a:ext>
             </a:extLst>
           </p:cNvPr>
@@ -11226,7 +11226,7 @@
           <p:cNvPr id="3" name="">
             <a:extLst xmlns:a="http://schemas.openxmlformats.org/drawingml/2006/main">
               <a:ext uri="{FF2B5EF4-FFF2-40B4-BE49-F238E27FC236}">
-                <a16:creationId xmlns:a16="http://schemas.microsoft.com/office/drawing/2014/main" id="{E3237B83-BE81-4750-BA18-C35BA40EB905}"/>
+                <a16:creationId xmlns:a16="http://schemas.microsoft.com/office/drawing/2014/main" id="{74920A4F-8A2D-4BE1-BA12-E48DE7282519}"/>
               </a:ext>
             </a:extLst>
           </p:cNvPr>
@@ -11276,7 +11276,7 @@
           <p:cNvPr id="4" name="">
             <a:extLst xmlns:a="http://schemas.openxmlformats.org/drawingml/2006/main">
               <a:ext uri="{FF2B5EF4-FFF2-40B4-BE49-F238E27FC236}">
-                <a16:creationId xmlns:a16="http://schemas.microsoft.com/office/drawing/2014/main" id="{8CC97AA4-FEC4-482E-9E1E-66B0A89FFE8A}"/>
+                <a16:creationId xmlns:a16="http://schemas.microsoft.com/office/drawing/2014/main" id="{509D4869-AA4A-472E-8EEC-14131B91668F}"/>
               </a:ext>
             </a:extLst>
           </p:cNvPr>
@@ -11326,7 +11326,7 @@
           <p:cNvPr id="5" name="">
             <a:extLst xmlns:a="http://schemas.openxmlformats.org/drawingml/2006/main">
               <a:ext uri="{FF2B5EF4-FFF2-40B4-BE49-F238E27FC236}">
-                <a16:creationId xmlns:a16="http://schemas.microsoft.com/office/drawing/2014/main" id="{3815D2E3-6DA5-4A91-AA38-A5B1B8A6D82B}"/>
+                <a16:creationId xmlns:a16="http://schemas.microsoft.com/office/drawing/2014/main" id="{89624453-0CD4-49EA-BF45-2C1E040EF790}"/>
               </a:ext>
             </a:extLst>
           </p:cNvPr>
@@ -11376,7 +11376,7 @@
           <p:cNvPr id="6" name="">
             <a:extLst xmlns:a="http://schemas.openxmlformats.org/drawingml/2006/main">
               <a:ext uri="{FF2B5EF4-FFF2-40B4-BE49-F238E27FC236}">
-                <a16:creationId xmlns:a16="http://schemas.microsoft.com/office/drawing/2014/main" id="{E000C3A9-D2E0-4A3A-9039-16178C5DB1F6}"/>
+                <a16:creationId xmlns:a16="http://schemas.microsoft.com/office/drawing/2014/main" id="{2363B149-8BB8-4C47-A53A-D669E07C4EEC}"/>
               </a:ext>
             </a:extLst>
           </p:cNvPr>
@@ -11426,7 +11426,7 @@
           <p:cNvPr id="7" name="">
             <a:extLst xmlns:a="http://schemas.openxmlformats.org/drawingml/2006/main">
               <a:ext uri="{FF2B5EF4-FFF2-40B4-BE49-F238E27FC236}">
-                <a16:creationId xmlns:a16="http://schemas.microsoft.com/office/drawing/2014/main" id="{1E8C025C-4C66-43A5-B51D-D398889A9B2B}"/>
+                <a16:creationId xmlns:a16="http://schemas.microsoft.com/office/drawing/2014/main" id="{5EBA04CD-A361-42AB-8A7E-9E85D025D4F7}"/>
               </a:ext>
             </a:extLst>
           </p:cNvPr>
@@ -11476,7 +11476,7 @@
           <p:cNvPr id="8" name="">
             <a:extLst xmlns:a="http://schemas.openxmlformats.org/drawingml/2006/main">
               <a:ext uri="{FF2B5EF4-FFF2-40B4-BE49-F238E27FC236}">
-                <a16:creationId xmlns:a16="http://schemas.microsoft.com/office/drawing/2014/main" id="{03E2354A-D0EC-4B87-B140-F4B2A34DAE09}"/>
+                <a16:creationId xmlns:a16="http://schemas.microsoft.com/office/drawing/2014/main" id="{EED8BDD8-FF8E-4A38-8596-9582C781C2AF}"/>
               </a:ext>
             </a:extLst>
           </p:cNvPr>
@@ -11526,7 +11526,7 @@
           <p:cNvPr id="9" name="">
             <a:extLst xmlns:a="http://schemas.openxmlformats.org/drawingml/2006/main">
               <a:ext uri="{FF2B5EF4-FFF2-40B4-BE49-F238E27FC236}">
-                <a16:creationId xmlns:a16="http://schemas.microsoft.com/office/drawing/2014/main" id="{118E8327-32B1-4339-A18F-C35CB790DC57}"/>
+                <a16:creationId xmlns:a16="http://schemas.microsoft.com/office/drawing/2014/main" id="{ECED1960-6F35-4713-A38B-D6EF76E89881}"/>
               </a:ext>
             </a:extLst>
           </p:cNvPr>
@@ -11559,7 +11559,7 @@
           <p:cNvPr id="10" name="">
             <a:extLst xmlns:a="http://schemas.openxmlformats.org/drawingml/2006/main">
               <a:ext uri="{FF2B5EF4-FFF2-40B4-BE49-F238E27FC236}">
-                <a16:creationId xmlns:a16="http://schemas.microsoft.com/office/drawing/2014/main" id="{0980E8BE-849D-4823-90EF-0C1A628B5F9E}"/>
+                <a16:creationId xmlns:a16="http://schemas.microsoft.com/office/drawing/2014/main" id="{54280FA1-48CA-4BE0-A52E-EE9F5BC50B80}"/>
               </a:ext>
             </a:extLst>
           </p:cNvPr>
@@ -11609,7 +11609,7 @@
           <p:cNvPr id="11" name="">
             <a:extLst xmlns:a="http://schemas.openxmlformats.org/drawingml/2006/main">
               <a:ext uri="{FF2B5EF4-FFF2-40B4-BE49-F238E27FC236}">
-                <a16:creationId xmlns:a16="http://schemas.microsoft.com/office/drawing/2014/main" id="{ED4DD83B-51A8-481A-85DE-AB439485A8E0}"/>
+                <a16:creationId xmlns:a16="http://schemas.microsoft.com/office/drawing/2014/main" id="{D970627C-442F-4ED7-B650-93F7066E38E6}"/>
               </a:ext>
             </a:extLst>
           </p:cNvPr>
@@ -11648,7 +11648,7 @@
           <p:nvPr/>
         </p:nvPicPr>
         <p:blipFill>
-          <a:blip xmlns:r="http://schemas.openxmlformats.org/officeDocument/2006/relationships" xmlns:a="http://schemas.openxmlformats.org/drawingml/2006/main" r:embed="Ra547890c625e45dd"/>
+          <a:blip xmlns:r="http://schemas.openxmlformats.org/officeDocument/2006/relationships" xmlns:a="http://schemas.openxmlformats.org/drawingml/2006/main" r:embed="R630039daa7834f0b"/>
           <a:stretch xmlns:a="http://schemas.openxmlformats.org/drawingml/2006/main"/>
         </p:blipFill>
         <p:spPr>
@@ -11666,7 +11666,7 @@
     </p:spTree>
     <p:extLst>
       <p:ext uri="{BB962C8B-B14F-4D97-AF65-F5344CB8AC3E}">
-        <p14:creationId xmlns:p14="http://schemas.microsoft.com/office/powerpoint/2010/main" val="938194265"/>
+        <p14:creationId xmlns:p14="http://schemas.microsoft.com/office/powerpoint/2010/main" val="234082397"/>
       </p:ext>
     </p:extLst>
   </p:cSld>
@@ -11697,7 +11697,7 @@
           <p:cNvPr id="23" name="">
             <a:extLst xmlns:a="http://schemas.openxmlformats.org/drawingml/2006/main">
               <a:ext uri="{FF2B5EF4-FFF2-40B4-BE49-F238E27FC236}">
-                <a16:creationId xmlns:a16="http://schemas.microsoft.com/office/drawing/2014/main" id="{2D9114F7-16EF-4818-8C64-DA4F067787F0}"/>
+                <a16:creationId xmlns:a16="http://schemas.microsoft.com/office/drawing/2014/main" id="{614026ED-F820-4C51-97A3-7BA86FBA7A94}"/>
               </a:ext>
             </a:extLst>
           </p:cNvPr>
@@ -11747,7 +11747,7 @@
           <p:cNvPr id="2" name="">
             <a:extLst xmlns:a="http://schemas.openxmlformats.org/drawingml/2006/main">
               <a:ext uri="{FF2B5EF4-FFF2-40B4-BE49-F238E27FC236}">
-                <a16:creationId xmlns:a16="http://schemas.microsoft.com/office/drawing/2014/main" id="{2B7B8CDF-FA78-48CA-A733-C2EAEAF6069C}"/>
+                <a16:creationId xmlns:a16="http://schemas.microsoft.com/office/drawing/2014/main" id="{53ACBDA0-304C-4F42-B892-C7625CB4FEB3}"/>
               </a:ext>
             </a:extLst>
           </p:cNvPr>
@@ -11797,7 +11797,7 @@
           <p:cNvPr id="3" name="">
             <a:extLst xmlns:a="http://schemas.openxmlformats.org/drawingml/2006/main">
               <a:ext uri="{FF2B5EF4-FFF2-40B4-BE49-F238E27FC236}">
-                <a16:creationId xmlns:a16="http://schemas.microsoft.com/office/drawing/2014/main" id="{056FA361-37F8-405F-85E8-405E5A951A84}"/>
+                <a16:creationId xmlns:a16="http://schemas.microsoft.com/office/drawing/2014/main" id="{99712C98-B7A8-4ACC-AFC4-D4DD853659D5}"/>
               </a:ext>
             </a:extLst>
           </p:cNvPr>
@@ -11847,7 +11847,7 @@
           <p:cNvPr id="4" name="">
             <a:extLst xmlns:a="http://schemas.openxmlformats.org/drawingml/2006/main">
               <a:ext uri="{FF2B5EF4-FFF2-40B4-BE49-F238E27FC236}">
-                <a16:creationId xmlns:a16="http://schemas.microsoft.com/office/drawing/2014/main" id="{73D3AD33-9FE5-4469-B5AC-BAA9B6C08837}"/>
+                <a16:creationId xmlns:a16="http://schemas.microsoft.com/office/drawing/2014/main" id="{654636C9-5AFF-468E-8C28-F6B86D02E141}"/>
               </a:ext>
             </a:extLst>
           </p:cNvPr>
@@ -11897,7 +11897,7 @@
           <p:cNvPr id="5" name="">
             <a:extLst xmlns:a="http://schemas.openxmlformats.org/drawingml/2006/main">
               <a:ext uri="{FF2B5EF4-FFF2-40B4-BE49-F238E27FC236}">
-                <a16:creationId xmlns:a16="http://schemas.microsoft.com/office/drawing/2014/main" id="{52EB87DD-3B10-4B3D-8A1A-F54C40E523F8}"/>
+                <a16:creationId xmlns:a16="http://schemas.microsoft.com/office/drawing/2014/main" id="{8DAED111-579C-4B2D-A25E-9C3C15F6C5B2}"/>
               </a:ext>
             </a:extLst>
           </p:cNvPr>
@@ -11947,7 +11947,7 @@
           <p:cNvPr id="6" name="">
             <a:extLst xmlns:a="http://schemas.openxmlformats.org/drawingml/2006/main">
               <a:ext uri="{FF2B5EF4-FFF2-40B4-BE49-F238E27FC236}">
-                <a16:creationId xmlns:a16="http://schemas.microsoft.com/office/drawing/2014/main" id="{5080ED04-D287-4D7A-962A-94088F3BD8C1}"/>
+                <a16:creationId xmlns:a16="http://schemas.microsoft.com/office/drawing/2014/main" id="{D1506F09-ABB4-4286-B3A3-9DD2346EC5AE}"/>
               </a:ext>
             </a:extLst>
           </p:cNvPr>
@@ -11997,7 +11997,7 @@
           <p:cNvPr id="7" name="">
             <a:extLst xmlns:a="http://schemas.openxmlformats.org/drawingml/2006/main">
               <a:ext uri="{FF2B5EF4-FFF2-40B4-BE49-F238E27FC236}">
-                <a16:creationId xmlns:a16="http://schemas.microsoft.com/office/drawing/2014/main" id="{DA775C91-717B-4A1F-8F04-6E0574A2C081}"/>
+                <a16:creationId xmlns:a16="http://schemas.microsoft.com/office/drawing/2014/main" id="{0EB515A4-7D00-4C78-9903-253302946ED1}"/>
               </a:ext>
             </a:extLst>
           </p:cNvPr>
@@ -12047,7 +12047,7 @@
           <p:cNvPr id="8" name="">
             <a:extLst xmlns:a="http://schemas.openxmlformats.org/drawingml/2006/main">
               <a:ext uri="{FF2B5EF4-FFF2-40B4-BE49-F238E27FC236}">
-                <a16:creationId xmlns:a16="http://schemas.microsoft.com/office/drawing/2014/main" id="{AFF6AE09-5F7B-409F-89E8-1DC2935AF57A}"/>
+                <a16:creationId xmlns:a16="http://schemas.microsoft.com/office/drawing/2014/main" id="{6599405D-B203-409A-B1A1-CA3CF2F74F7F}"/>
               </a:ext>
             </a:extLst>
           </p:cNvPr>
@@ -12097,7 +12097,7 @@
           <p:cNvPr id="9" name="">
             <a:extLst xmlns:a="http://schemas.openxmlformats.org/drawingml/2006/main">
               <a:ext uri="{FF2B5EF4-FFF2-40B4-BE49-F238E27FC236}">
-                <a16:creationId xmlns:a16="http://schemas.microsoft.com/office/drawing/2014/main" id="{E57551E0-872F-4020-9DC3-6E6CE714F039}"/>
+                <a16:creationId xmlns:a16="http://schemas.microsoft.com/office/drawing/2014/main" id="{87DAE5AF-E500-4CE3-BE92-0A2395226E0E}"/>
               </a:ext>
             </a:extLst>
           </p:cNvPr>
@@ -12147,7 +12147,7 @@
           <p:cNvPr id="10" name="">
             <a:extLst xmlns:a="http://schemas.openxmlformats.org/drawingml/2006/main">
               <a:ext uri="{FF2B5EF4-FFF2-40B4-BE49-F238E27FC236}">
-                <a16:creationId xmlns:a16="http://schemas.microsoft.com/office/drawing/2014/main" id="{65BA0EC6-26A5-4AD6-8219-A67ED5B36373}"/>
+                <a16:creationId xmlns:a16="http://schemas.microsoft.com/office/drawing/2014/main" id="{157D1844-C32D-4BC4-8039-5B7471BAB2F4}"/>
               </a:ext>
             </a:extLst>
           </p:cNvPr>
@@ -12182,7 +12182,7 @@
           <p:cNvPr id="11" name="">
             <a:extLst xmlns:a="http://schemas.openxmlformats.org/drawingml/2006/main">
               <a:ext uri="{FF2B5EF4-FFF2-40B4-BE49-F238E27FC236}">
-                <a16:creationId xmlns:a16="http://schemas.microsoft.com/office/drawing/2014/main" id="{0DDDAD09-B897-4542-BDBD-73E2F023B2D0}"/>
+                <a16:creationId xmlns:a16="http://schemas.microsoft.com/office/drawing/2014/main" id="{1C0E785C-5127-459C-A021-4331B4784249}"/>
               </a:ext>
             </a:extLst>
           </p:cNvPr>
@@ -12232,7 +12232,7 @@
           <p:cNvPr id="12" name="">
             <a:extLst xmlns:a="http://schemas.openxmlformats.org/drawingml/2006/main">
               <a:ext uri="{FF2B5EF4-FFF2-40B4-BE49-F238E27FC236}">
-                <a16:creationId xmlns:a16="http://schemas.microsoft.com/office/drawing/2014/main" id="{0F5256AB-3B3F-4311-BB00-CC02FB6EE8D2}"/>
+                <a16:creationId xmlns:a16="http://schemas.microsoft.com/office/drawing/2014/main" id="{65F9AE14-2075-4B79-8333-85A335F599D2}"/>
               </a:ext>
             </a:extLst>
           </p:cNvPr>
@@ -12282,7 +12282,7 @@
           <p:cNvPr id="13" name="">
             <a:extLst xmlns:a="http://schemas.openxmlformats.org/drawingml/2006/main">
               <a:ext uri="{FF2B5EF4-FFF2-40B4-BE49-F238E27FC236}">
-                <a16:creationId xmlns:a16="http://schemas.microsoft.com/office/drawing/2014/main" id="{E37BB7BC-3CBD-4B74-B1D7-DCC476AADF28}"/>
+                <a16:creationId xmlns:a16="http://schemas.microsoft.com/office/drawing/2014/main" id="{05C2BF99-9432-4CEB-A26D-EDF5FA457080}"/>
               </a:ext>
             </a:extLst>
           </p:cNvPr>
@@ -12313,7 +12313,7 @@
           <p:cNvPr id="14" name="">
             <a:extLst xmlns:a="http://schemas.openxmlformats.org/drawingml/2006/main">
               <a:ext uri="{FF2B5EF4-FFF2-40B4-BE49-F238E27FC236}">
-                <a16:creationId xmlns:a16="http://schemas.microsoft.com/office/drawing/2014/main" id="{B8B2FD48-F795-4DF9-89ED-B98CA860805C}"/>
+                <a16:creationId xmlns:a16="http://schemas.microsoft.com/office/drawing/2014/main" id="{C66CAD7C-6A8D-4B1A-9437-FE0D0ABF1260}"/>
               </a:ext>
             </a:extLst>
           </p:cNvPr>
@@ -12363,7 +12363,7 @@
           <p:cNvPr id="15" name="">
             <a:extLst xmlns:a="http://schemas.openxmlformats.org/drawingml/2006/main">
               <a:ext uri="{FF2B5EF4-FFF2-40B4-BE49-F238E27FC236}">
-                <a16:creationId xmlns:a16="http://schemas.microsoft.com/office/drawing/2014/main" id="{E0EAF163-8BDC-438D-9EC8-154449D9347F}"/>
+                <a16:creationId xmlns:a16="http://schemas.microsoft.com/office/drawing/2014/main" id="{D89E1D70-413F-4AE7-B9D5-D825E0ECBF4C}"/>
               </a:ext>
             </a:extLst>
           </p:cNvPr>
@@ -12413,7 +12413,7 @@
           <p:cNvPr id="16" name="">
             <a:extLst xmlns:a="http://schemas.openxmlformats.org/drawingml/2006/main">
               <a:ext uri="{FF2B5EF4-FFF2-40B4-BE49-F238E27FC236}">
-                <a16:creationId xmlns:a16="http://schemas.microsoft.com/office/drawing/2014/main" id="{4972421B-6083-498B-87D2-DEA9C81A3594}"/>
+                <a16:creationId xmlns:a16="http://schemas.microsoft.com/office/drawing/2014/main" id="{DA7708FA-6D78-4E89-A50E-E182FD925696}"/>
               </a:ext>
             </a:extLst>
           </p:cNvPr>
@@ -12463,7 +12463,7 @@
           <p:cNvPr id="17" name="">
             <a:extLst xmlns:a="http://schemas.openxmlformats.org/drawingml/2006/main">
               <a:ext uri="{FF2B5EF4-FFF2-40B4-BE49-F238E27FC236}">
-                <a16:creationId xmlns:a16="http://schemas.microsoft.com/office/drawing/2014/main" id="{32EA3B74-4A3C-49A0-A3DF-849B2C56DF18}"/>
+                <a16:creationId xmlns:a16="http://schemas.microsoft.com/office/drawing/2014/main" id="{EE3A95E6-2885-4639-8BC6-0C423DB35459}"/>
               </a:ext>
             </a:extLst>
           </p:cNvPr>
@@ -12513,7 +12513,7 @@
           <p:cNvPr id="18" name="">
             <a:extLst xmlns:a="http://schemas.openxmlformats.org/drawingml/2006/main">
               <a:ext uri="{FF2B5EF4-FFF2-40B4-BE49-F238E27FC236}">
-                <a16:creationId xmlns:a16="http://schemas.microsoft.com/office/drawing/2014/main" id="{6A8646CC-39D3-4B4C-BDCD-9E43B33E75A8}"/>
+                <a16:creationId xmlns:a16="http://schemas.microsoft.com/office/drawing/2014/main" id="{C58D3DB2-7922-4999-B629-13FF293BDE16}"/>
               </a:ext>
             </a:extLst>
           </p:cNvPr>
@@ -12563,7 +12563,7 @@
           <p:cNvPr id="19" name="">
             <a:extLst xmlns:a="http://schemas.openxmlformats.org/drawingml/2006/main">
               <a:ext uri="{FF2B5EF4-FFF2-40B4-BE49-F238E27FC236}">
-                <a16:creationId xmlns:a16="http://schemas.microsoft.com/office/drawing/2014/main" id="{A5F1694E-6843-47A0-BBD1-5B1B104DE0BC}"/>
+                <a16:creationId xmlns:a16="http://schemas.microsoft.com/office/drawing/2014/main" id="{BBF91CFB-5F7D-41ED-8B75-B4D711C158DD}"/>
               </a:ext>
             </a:extLst>
           </p:cNvPr>
@@ -12613,7 +12613,7 @@
           <p:cNvPr id="20" name="">
             <a:extLst xmlns:a="http://schemas.openxmlformats.org/drawingml/2006/main">
               <a:ext uri="{FF2B5EF4-FFF2-40B4-BE49-F238E27FC236}">
-                <a16:creationId xmlns:a16="http://schemas.microsoft.com/office/drawing/2014/main" id="{F9D2C01C-8A73-4057-A40C-FD3F821EACFA}"/>
+                <a16:creationId xmlns:a16="http://schemas.microsoft.com/office/drawing/2014/main" id="{E7371F82-5AE1-4528-A7BA-03D098CB9811}"/>
               </a:ext>
             </a:extLst>
           </p:cNvPr>
@@ -12663,7 +12663,7 @@
           <p:cNvPr id="21" name="">
             <a:extLst xmlns:a="http://schemas.openxmlformats.org/drawingml/2006/main">
               <a:ext uri="{FF2B5EF4-FFF2-40B4-BE49-F238E27FC236}">
-                <a16:creationId xmlns:a16="http://schemas.microsoft.com/office/drawing/2014/main" id="{2E2A651D-802E-4FA9-9ED5-197A63210585}"/>
+                <a16:creationId xmlns:a16="http://schemas.microsoft.com/office/drawing/2014/main" id="{7760DAAD-D7E1-4743-9B36-D7B1C17CF861}"/>
               </a:ext>
             </a:extLst>
           </p:cNvPr>
@@ -12713,7 +12713,7 @@
           <p:cNvPr id="22" name="">
             <a:extLst xmlns:a="http://schemas.openxmlformats.org/drawingml/2006/main">
               <a:ext uri="{FF2B5EF4-FFF2-40B4-BE49-F238E27FC236}">
-                <a16:creationId xmlns:a16="http://schemas.microsoft.com/office/drawing/2014/main" id="{BCC1E032-C562-43C3-A112-BFBA7D248373}"/>
+                <a16:creationId xmlns:a16="http://schemas.microsoft.com/office/drawing/2014/main" id="{FA872A6F-4EC0-428E-9F1B-6F8B1DED6EDB}"/>
               </a:ext>
             </a:extLst>
           </p:cNvPr>
@@ -12761,7 +12761,7 @@
     </p:spTree>
     <p:extLst>
       <p:ext uri="{BB962C8B-B14F-4D97-AF65-F5344CB8AC3E}">
-        <p14:creationId xmlns:p14="http://schemas.microsoft.com/office/powerpoint/2010/main" val="1227516645"/>
+        <p14:creationId xmlns:p14="http://schemas.microsoft.com/office/powerpoint/2010/main" val="686969988"/>
       </p:ext>
     </p:extLst>
   </p:cSld>
@@ -12792,7 +12792,7 @@
           <p:cNvPr id="11" name="">
             <a:extLst xmlns:a="http://schemas.openxmlformats.org/drawingml/2006/main">
               <a:ext uri="{FF2B5EF4-FFF2-40B4-BE49-F238E27FC236}">
-                <a16:creationId xmlns:a16="http://schemas.microsoft.com/office/drawing/2014/main" id="{2CFBEAE6-0520-48D8-B38F-456010FA37E3}"/>
+                <a16:creationId xmlns:a16="http://schemas.microsoft.com/office/drawing/2014/main" id="{81F08BC1-3756-42F5-9377-D1FE75709C10}"/>
               </a:ext>
             </a:extLst>
           </p:cNvPr>
@@ -12842,7 +12842,7 @@
           <p:cNvPr id="2" name="">
             <a:extLst xmlns:a="http://schemas.openxmlformats.org/drawingml/2006/main">
               <a:ext uri="{FF2B5EF4-FFF2-40B4-BE49-F238E27FC236}">
-                <a16:creationId xmlns:a16="http://schemas.microsoft.com/office/drawing/2014/main" id="{ADC94C70-7EB8-4BA3-B5AC-8934D2A3E812}"/>
+                <a16:creationId xmlns:a16="http://schemas.microsoft.com/office/drawing/2014/main" id="{2990BBC2-04F8-41A9-B76F-B7CFA75FAE38}"/>
               </a:ext>
             </a:extLst>
           </p:cNvPr>
@@ -12892,7 +12892,7 @@
           <p:cNvPr id="3" name="">
             <a:extLst xmlns:a="http://schemas.openxmlformats.org/drawingml/2006/main">
               <a:ext uri="{FF2B5EF4-FFF2-40B4-BE49-F238E27FC236}">
-                <a16:creationId xmlns:a16="http://schemas.microsoft.com/office/drawing/2014/main" id="{69A8889D-6133-4363-B65E-EB82C7934C80}"/>
+                <a16:creationId xmlns:a16="http://schemas.microsoft.com/office/drawing/2014/main" id="{C82FEC60-920C-4AC0-958A-2F5C0CCE15C3}"/>
               </a:ext>
             </a:extLst>
           </p:cNvPr>
@@ -12942,7 +12942,7 @@
           <p:cNvPr id="4" name="">
             <a:extLst xmlns:a="http://schemas.openxmlformats.org/drawingml/2006/main">
               <a:ext uri="{FF2B5EF4-FFF2-40B4-BE49-F238E27FC236}">
-                <a16:creationId xmlns:a16="http://schemas.microsoft.com/office/drawing/2014/main" id="{EF87F7E7-BB80-4B93-9FB3-C49E9C15B820}"/>
+                <a16:creationId xmlns:a16="http://schemas.microsoft.com/office/drawing/2014/main" id="{F9C37E6C-FADA-4C66-9AE4-12F5A55E3E5D}"/>
               </a:ext>
             </a:extLst>
           </p:cNvPr>
@@ -12977,7 +12977,7 @@
           <p:cNvPr id="5" name="">
             <a:extLst xmlns:a="http://schemas.openxmlformats.org/drawingml/2006/main">
               <a:ext uri="{FF2B5EF4-FFF2-40B4-BE49-F238E27FC236}">
-                <a16:creationId xmlns:a16="http://schemas.microsoft.com/office/drawing/2014/main" id="{60EBDDEA-59D5-4832-9432-6567F57F8D39}"/>
+                <a16:creationId xmlns:a16="http://schemas.microsoft.com/office/drawing/2014/main" id="{DE2B7FF7-A0D0-4B78-9D9B-1AD494487F3E}"/>
               </a:ext>
             </a:extLst>
           </p:cNvPr>
@@ -13027,7 +13027,7 @@
           <p:cNvPr id="6" name="">
             <a:extLst xmlns:a="http://schemas.openxmlformats.org/drawingml/2006/main">
               <a:ext uri="{FF2B5EF4-FFF2-40B4-BE49-F238E27FC236}">
-                <a16:creationId xmlns:a16="http://schemas.microsoft.com/office/drawing/2014/main" id="{7C4107F4-56A5-4936-B91B-8E017CC50C2F}"/>
+                <a16:creationId xmlns:a16="http://schemas.microsoft.com/office/drawing/2014/main" id="{F019C9C9-6717-4EAE-A6FE-D3F8A2E4249F}"/>
               </a:ext>
             </a:extLst>
           </p:cNvPr>
@@ -13077,7 +13077,7 @@
           <p:cNvPr id="7" name="">
             <a:extLst xmlns:a="http://schemas.openxmlformats.org/drawingml/2006/main">
               <a:ext uri="{FF2B5EF4-FFF2-40B4-BE49-F238E27FC236}">
-                <a16:creationId xmlns:a16="http://schemas.microsoft.com/office/drawing/2014/main" id="{0528DAF5-A206-4498-B862-09EFD2C587AF}"/>
+                <a16:creationId xmlns:a16="http://schemas.microsoft.com/office/drawing/2014/main" id="{CBA9BA85-82E5-4298-B9C3-0364099CDAF4}"/>
               </a:ext>
             </a:extLst>
           </p:cNvPr>
@@ -13112,7 +13112,7 @@
           <p:cNvPr id="8" name="">
             <a:extLst xmlns:a="http://schemas.openxmlformats.org/drawingml/2006/main">
               <a:ext uri="{FF2B5EF4-FFF2-40B4-BE49-F238E27FC236}">
-                <a16:creationId xmlns:a16="http://schemas.microsoft.com/office/drawing/2014/main" id="{E119A371-F897-44C2-9C4C-ADAE1ABB5F10}"/>
+                <a16:creationId xmlns:a16="http://schemas.microsoft.com/office/drawing/2014/main" id="{4366314A-96BE-4D8D-9EF7-1C8EE3E255EE}"/>
               </a:ext>
             </a:extLst>
           </p:cNvPr>
@@ -13162,7 +13162,7 @@
           <p:cNvPr id="9" name="">
             <a:extLst xmlns:a="http://schemas.openxmlformats.org/drawingml/2006/main">
               <a:ext uri="{FF2B5EF4-FFF2-40B4-BE49-F238E27FC236}">
-                <a16:creationId xmlns:a16="http://schemas.microsoft.com/office/drawing/2014/main" id="{2A5C55D8-7B72-46F0-A677-0A26366A1070}"/>
+                <a16:creationId xmlns:a16="http://schemas.microsoft.com/office/drawing/2014/main" id="{83E53CD3-7CC5-458E-89B2-6BE4EDBF2D29}"/>
               </a:ext>
             </a:extLst>
           </p:cNvPr>
@@ -13212,7 +13212,7 @@
           <p:cNvPr id="10" name="">
             <a:extLst xmlns:a="http://schemas.openxmlformats.org/drawingml/2006/main">
               <a:ext uri="{FF2B5EF4-FFF2-40B4-BE49-F238E27FC236}">
-                <a16:creationId xmlns:a16="http://schemas.microsoft.com/office/drawing/2014/main" id="{752AC6E3-7260-4244-BEAF-D14EA0C0C041}"/>
+                <a16:creationId xmlns:a16="http://schemas.microsoft.com/office/drawing/2014/main" id="{DBD6398D-F700-424A-AAF4-C9335CB02C4A}"/>
               </a:ext>
             </a:extLst>
           </p:cNvPr>
@@ -13260,7 +13260,7 @@
     </p:spTree>
     <p:extLst>
       <p:ext uri="{BB962C8B-B14F-4D97-AF65-F5344CB8AC3E}">
-        <p14:creationId xmlns:p14="http://schemas.microsoft.com/office/powerpoint/2010/main" val="2129929983"/>
+        <p14:creationId xmlns:p14="http://schemas.microsoft.com/office/powerpoint/2010/main" val="1816489873"/>
       </p:ext>
     </p:extLst>
   </p:cSld>
@@ -13291,7 +13291,7 @@
           <p:cNvPr id="23" name="">
             <a:extLst xmlns:a="http://schemas.openxmlformats.org/drawingml/2006/main">
               <a:ext uri="{FF2B5EF4-FFF2-40B4-BE49-F238E27FC236}">
-                <a16:creationId xmlns:a16="http://schemas.microsoft.com/office/drawing/2014/main" id="{8CF93BB8-B669-4189-BD9B-B371C31EE147}"/>
+                <a16:creationId xmlns:a16="http://schemas.microsoft.com/office/drawing/2014/main" id="{E988DCA1-8B3D-4353-8443-8BDB1EA322B7}"/>
               </a:ext>
             </a:extLst>
           </p:cNvPr>
@@ -13341,7 +13341,7 @@
           <p:cNvPr id="2" name="">
             <a:extLst xmlns:a="http://schemas.openxmlformats.org/drawingml/2006/main">
               <a:ext uri="{FF2B5EF4-FFF2-40B4-BE49-F238E27FC236}">
-                <a16:creationId xmlns:a16="http://schemas.microsoft.com/office/drawing/2014/main" id="{451FD27B-997B-44AA-B9CF-4BAE59522476}"/>
+                <a16:creationId xmlns:a16="http://schemas.microsoft.com/office/drawing/2014/main" id="{339648F9-B1F9-421F-8390-116339300F06}"/>
               </a:ext>
             </a:extLst>
           </p:cNvPr>
@@ -13391,7 +13391,7 @@
           <p:cNvPr id="3" name="">
             <a:extLst xmlns:a="http://schemas.openxmlformats.org/drawingml/2006/main">
               <a:ext uri="{FF2B5EF4-FFF2-40B4-BE49-F238E27FC236}">
-                <a16:creationId xmlns:a16="http://schemas.microsoft.com/office/drawing/2014/main" id="{C618F9F3-D2C2-429E-A39E-453AA1C6EA88}"/>
+                <a16:creationId xmlns:a16="http://schemas.microsoft.com/office/drawing/2014/main" id="{885521C0-E163-4609-98EB-3368AB3C5646}"/>
               </a:ext>
             </a:extLst>
           </p:cNvPr>
@@ -13441,7 +13441,7 @@
           <p:cNvPr id="4" name="">
             <a:extLst xmlns:a="http://schemas.openxmlformats.org/drawingml/2006/main">
               <a:ext uri="{FF2B5EF4-FFF2-40B4-BE49-F238E27FC236}">
-                <a16:creationId xmlns:a16="http://schemas.microsoft.com/office/drawing/2014/main" id="{0819BF29-3252-42CB-90B5-256D40573045}"/>
+                <a16:creationId xmlns:a16="http://schemas.microsoft.com/office/drawing/2014/main" id="{0BA89C93-D2FA-44F0-AABD-B3E43A4FE7AB}"/>
               </a:ext>
             </a:extLst>
           </p:cNvPr>
@@ -13491,7 +13491,7 @@
           <p:cNvPr id="5" name="">
             <a:extLst xmlns:a="http://schemas.openxmlformats.org/drawingml/2006/main">
               <a:ext uri="{FF2B5EF4-FFF2-40B4-BE49-F238E27FC236}">
-                <a16:creationId xmlns:a16="http://schemas.microsoft.com/office/drawing/2014/main" id="{4EBEBD8C-D8B6-46DD-B6B0-72D08507639D}"/>
+                <a16:creationId xmlns:a16="http://schemas.microsoft.com/office/drawing/2014/main" id="{A1FFDDF7-7D45-49E4-B751-66A0064FED9E}"/>
               </a:ext>
             </a:extLst>
           </p:cNvPr>
@@ -13524,7 +13524,7 @@
           <p:cNvPr id="6" name="">
             <a:extLst xmlns:a="http://schemas.openxmlformats.org/drawingml/2006/main">
               <a:ext uri="{FF2B5EF4-FFF2-40B4-BE49-F238E27FC236}">
-                <a16:creationId xmlns:a16="http://schemas.microsoft.com/office/drawing/2014/main" id="{85815EC7-9B1A-4D73-83F4-AD47A04E95DA}"/>
+                <a16:creationId xmlns:a16="http://schemas.microsoft.com/office/drawing/2014/main" id="{32045F85-ABE5-4F72-A621-36AFA273CCB5}"/>
               </a:ext>
             </a:extLst>
           </p:cNvPr>
@@ -13574,7 +13574,7 @@
           <p:cNvPr id="7" name="">
             <a:extLst xmlns:a="http://schemas.openxmlformats.org/drawingml/2006/main">
               <a:ext uri="{FF2B5EF4-FFF2-40B4-BE49-F238E27FC236}">
-                <a16:creationId xmlns:a16="http://schemas.microsoft.com/office/drawing/2014/main" id="{084A4C3A-99E1-4A49-A244-8656BCFCA5BB}"/>
+                <a16:creationId xmlns:a16="http://schemas.microsoft.com/office/drawing/2014/main" id="{A5093CFA-2533-4899-8A19-F0D374C786F7}"/>
               </a:ext>
             </a:extLst>
           </p:cNvPr>
@@ -13609,7 +13609,7 @@
           <p:cNvPr id="8" name="">
             <a:extLst xmlns:a="http://schemas.openxmlformats.org/drawingml/2006/main">
               <a:ext uri="{FF2B5EF4-FFF2-40B4-BE49-F238E27FC236}">
-                <a16:creationId xmlns:a16="http://schemas.microsoft.com/office/drawing/2014/main" id="{5E07F2C4-8B71-48AD-B9F6-4DC696E970D5}"/>
+                <a16:creationId xmlns:a16="http://schemas.microsoft.com/office/drawing/2014/main" id="{734E1189-9BC2-47FF-BB9F-3260D65138E1}"/>
               </a:ext>
             </a:extLst>
           </p:cNvPr>
@@ -13640,7 +13640,7 @@
           <p:cNvPr id="9" name="">
             <a:extLst xmlns:a="http://schemas.openxmlformats.org/drawingml/2006/main">
               <a:ext uri="{FF2B5EF4-FFF2-40B4-BE49-F238E27FC236}">
-                <a16:creationId xmlns:a16="http://schemas.microsoft.com/office/drawing/2014/main" id="{0C254597-A149-4C51-9991-9F16BEADA8AD}"/>
+                <a16:creationId xmlns:a16="http://schemas.microsoft.com/office/drawing/2014/main" id="{3BB918AB-411D-46FF-BE68-BA4230B2C47C}"/>
               </a:ext>
             </a:extLst>
           </p:cNvPr>
@@ -13690,7 +13690,7 @@
           <p:cNvPr id="10" name="">
             <a:extLst xmlns:a="http://schemas.openxmlformats.org/drawingml/2006/main">
               <a:ext uri="{FF2B5EF4-FFF2-40B4-BE49-F238E27FC236}">
-                <a16:creationId xmlns:a16="http://schemas.microsoft.com/office/drawing/2014/main" id="{3948D439-8D4F-4FED-822E-3CB52399CC6B}"/>
+                <a16:creationId xmlns:a16="http://schemas.microsoft.com/office/drawing/2014/main" id="{50B7177E-1040-4A89-8913-A40F292CCAB6}"/>
               </a:ext>
             </a:extLst>
           </p:cNvPr>
@@ -13740,7 +13740,7 @@
           <p:cNvPr id="11" name="">
             <a:extLst xmlns:a="http://schemas.openxmlformats.org/drawingml/2006/main">
               <a:ext uri="{FF2B5EF4-FFF2-40B4-BE49-F238E27FC236}">
-                <a16:creationId xmlns:a16="http://schemas.microsoft.com/office/drawing/2014/main" id="{C1EEA6F6-E9B3-4858-8796-BA5281DC3B56}"/>
+                <a16:creationId xmlns:a16="http://schemas.microsoft.com/office/drawing/2014/main" id="{4BEA4DD8-2E80-489C-8EA5-E5A6196143E9}"/>
               </a:ext>
             </a:extLst>
           </p:cNvPr>
@@ -13775,7 +13775,7 @@
           <p:cNvPr id="12" name="">
             <a:extLst xmlns:a="http://schemas.openxmlformats.org/drawingml/2006/main">
               <a:ext uri="{FF2B5EF4-FFF2-40B4-BE49-F238E27FC236}">
-                <a16:creationId xmlns:a16="http://schemas.microsoft.com/office/drawing/2014/main" id="{D9546252-A192-4F0C-AC70-D606A043FBA8}"/>
+                <a16:creationId xmlns:a16="http://schemas.microsoft.com/office/drawing/2014/main" id="{5AF9E5F2-D8E1-4629-BFF7-DB9E6E28D11A}"/>
               </a:ext>
             </a:extLst>
           </p:cNvPr>
@@ -13806,7 +13806,7 @@
           <p:cNvPr id="13" name="">
             <a:extLst xmlns:a="http://schemas.openxmlformats.org/drawingml/2006/main">
               <a:ext uri="{FF2B5EF4-FFF2-40B4-BE49-F238E27FC236}">
-                <a16:creationId xmlns:a16="http://schemas.microsoft.com/office/drawing/2014/main" id="{252D1A87-55E1-44FA-995E-8F904EEEFC4F}"/>
+                <a16:creationId xmlns:a16="http://schemas.microsoft.com/office/drawing/2014/main" id="{DBA35E5C-475F-4683-9030-433767AEE090}"/>
               </a:ext>
             </a:extLst>
           </p:cNvPr>
@@ -13856,7 +13856,7 @@
           <p:cNvPr id="14" name="">
             <a:extLst xmlns:a="http://schemas.openxmlformats.org/drawingml/2006/main">
               <a:ext uri="{FF2B5EF4-FFF2-40B4-BE49-F238E27FC236}">
-                <a16:creationId xmlns:a16="http://schemas.microsoft.com/office/drawing/2014/main" id="{A8D03AA5-5A42-410D-A284-655890A2D990}"/>
+                <a16:creationId xmlns:a16="http://schemas.microsoft.com/office/drawing/2014/main" id="{029E373E-A5AB-4DDF-8D89-B42BB894D0DF}"/>
               </a:ext>
             </a:extLst>
           </p:cNvPr>
@@ -13906,7 +13906,7 @@
           <p:cNvPr id="15" name="">
             <a:extLst xmlns:a="http://schemas.openxmlformats.org/drawingml/2006/main">
               <a:ext uri="{FF2B5EF4-FFF2-40B4-BE49-F238E27FC236}">
-                <a16:creationId xmlns:a16="http://schemas.microsoft.com/office/drawing/2014/main" id="{F2251545-F8FD-4274-A3A5-1CC2D49F996B}"/>
+                <a16:creationId xmlns:a16="http://schemas.microsoft.com/office/drawing/2014/main" id="{A0047745-9D7C-4095-924A-3DBC9264162B}"/>
               </a:ext>
             </a:extLst>
           </p:cNvPr>
@@ -13941,7 +13941,7 @@
           <p:cNvPr id="16" name="">
             <a:extLst xmlns:a="http://schemas.openxmlformats.org/drawingml/2006/main">
               <a:ext uri="{FF2B5EF4-FFF2-40B4-BE49-F238E27FC236}">
-                <a16:creationId xmlns:a16="http://schemas.microsoft.com/office/drawing/2014/main" id="{038A2EC2-EF90-45D7-92BA-BACAE174A482}"/>
+                <a16:creationId xmlns:a16="http://schemas.microsoft.com/office/drawing/2014/main" id="{FFD4EBD8-DACB-46D5-BB28-588F87F0BB21}"/>
               </a:ext>
             </a:extLst>
           </p:cNvPr>
@@ -13972,7 +13972,7 @@
           <p:cNvPr id="17" name="">
             <a:extLst xmlns:a="http://schemas.openxmlformats.org/drawingml/2006/main">
               <a:ext uri="{FF2B5EF4-FFF2-40B4-BE49-F238E27FC236}">
-                <a16:creationId xmlns:a16="http://schemas.microsoft.com/office/drawing/2014/main" id="{CE624A55-13FC-44A3-AC43-05161DA735BC}"/>
+                <a16:creationId xmlns:a16="http://schemas.microsoft.com/office/drawing/2014/main" id="{DB36CCB8-C4F6-4D9C-882B-6BD723B23077}"/>
               </a:ext>
             </a:extLst>
           </p:cNvPr>
@@ -14022,7 +14022,7 @@
           <p:cNvPr id="18" name="">
             <a:extLst xmlns:a="http://schemas.openxmlformats.org/drawingml/2006/main">
               <a:ext uri="{FF2B5EF4-FFF2-40B4-BE49-F238E27FC236}">
-                <a16:creationId xmlns:a16="http://schemas.microsoft.com/office/drawing/2014/main" id="{565B2065-30FF-404F-B7CC-06DF2757774E}"/>
+                <a16:creationId xmlns:a16="http://schemas.microsoft.com/office/drawing/2014/main" id="{9507A964-F594-4CBD-84A0-7468F94FFF7E}"/>
               </a:ext>
             </a:extLst>
           </p:cNvPr>
@@ -14072,7 +14072,7 @@
           <p:cNvPr id="19" name="">
             <a:extLst xmlns:a="http://schemas.openxmlformats.org/drawingml/2006/main">
               <a:ext uri="{FF2B5EF4-FFF2-40B4-BE49-F238E27FC236}">
-                <a16:creationId xmlns:a16="http://schemas.microsoft.com/office/drawing/2014/main" id="{97CD8182-7CEF-44D5-9222-EE1433507193}"/>
+                <a16:creationId xmlns:a16="http://schemas.microsoft.com/office/drawing/2014/main" id="{5ABFAD81-1D4E-4CF6-9D2D-33E433246820}"/>
               </a:ext>
             </a:extLst>
           </p:cNvPr>
@@ -14107,7 +14107,7 @@
           <p:cNvPr id="20" name="">
             <a:extLst xmlns:a="http://schemas.openxmlformats.org/drawingml/2006/main">
               <a:ext uri="{FF2B5EF4-FFF2-40B4-BE49-F238E27FC236}">
-                <a16:creationId xmlns:a16="http://schemas.microsoft.com/office/drawing/2014/main" id="{BB7E525D-8240-4684-A333-0767809C90EF}"/>
+                <a16:creationId xmlns:a16="http://schemas.microsoft.com/office/drawing/2014/main" id="{610FDD56-168C-4D51-9735-E106D07CE703}"/>
               </a:ext>
             </a:extLst>
           </p:cNvPr>
@@ -14138,7 +14138,7 @@
           <p:cNvPr id="21" name="">
             <a:extLst xmlns:a="http://schemas.openxmlformats.org/drawingml/2006/main">
               <a:ext uri="{FF2B5EF4-FFF2-40B4-BE49-F238E27FC236}">
-                <a16:creationId xmlns:a16="http://schemas.microsoft.com/office/drawing/2014/main" id="{040CE4FF-E319-46FE-B849-2B54DAAD0443}"/>
+                <a16:creationId xmlns:a16="http://schemas.microsoft.com/office/drawing/2014/main" id="{CDDF1D9C-8361-4861-B541-835382F60DB3}"/>
               </a:ext>
             </a:extLst>
           </p:cNvPr>
@@ -14188,7 +14188,7 @@
           <p:cNvPr id="22" name="">
             <a:extLst xmlns:a="http://schemas.openxmlformats.org/drawingml/2006/main">
               <a:ext uri="{FF2B5EF4-FFF2-40B4-BE49-F238E27FC236}">
-                <a16:creationId xmlns:a16="http://schemas.microsoft.com/office/drawing/2014/main" id="{796D0931-E1D7-4ABC-9C58-9270F27A589B}"/>
+                <a16:creationId xmlns:a16="http://schemas.microsoft.com/office/drawing/2014/main" id="{DD8B097B-E72B-4FC7-A29A-86946CF60785}"/>
               </a:ext>
             </a:extLst>
           </p:cNvPr>
@@ -14236,7 +14236,7 @@
     </p:spTree>
     <p:extLst>
       <p:ext uri="{BB962C8B-B14F-4D97-AF65-F5344CB8AC3E}">
-        <p14:creationId xmlns:p14="http://schemas.microsoft.com/office/powerpoint/2010/main" val="290361420"/>
+        <p14:creationId xmlns:p14="http://schemas.microsoft.com/office/powerpoint/2010/main" val="764795345"/>
       </p:ext>
     </p:extLst>
   </p:cSld>

</xml_diff>